<commit_message>
M6: strengthen Fishbone diagram template quality
</commit_message>
<xml_diff>
--- a/templates/ppt/methods/fishbone-diagram-template.pptx
+++ b/templates/ppt/methods/fishbone-diagram-template.pptx
@@ -15,6 +15,10 @@
     <p:sldId id="263" r:id="rId14"/>
     <p:sldId id="264" r:id="rId15"/>
     <p:sldId id="265" r:id="rId16"/>
+    <p:sldId id="266" r:id="rId17"/>
+    <p:sldId id="267" r:id="rId18"/>
+    <p:sldId id="268" r:id="rId19"/>
+    <p:sldId id="269" r:id="rId20"/>
   </p:sldIdLst>
   <p:sldSz cx="12191999" cy="6858000" type="screen4x3"/>
   <p:notesSz cx="6858000" cy="9144000"/>
@@ -3550,6 +3554,1531 @@
 </file>
 
 <file path=ppt/slides/slide10.xml><?xml version="1.0" encoding="utf-8"?>
+<p:sld xmlns:a="http://schemas.openxmlformats.org/drawingml/2006/main" xmlns:p="http://schemas.openxmlformats.org/presentationml/2006/main" xmlns:r="http://schemas.openxmlformats.org/officeDocument/2006/relationships">
+  <p:cSld>
+    <p:spTree>
+      <p:nvGrpSpPr>
+        <p:cNvPr id="1" name=""/>
+        <p:cNvGrpSpPr/>
+        <p:nvPr/>
+      </p:nvGrpSpPr>
+      <p:grpSpPr/>
+      <p:sp>
+        <p:nvSpPr>
+          <p:cNvPr id="2" name="TextBox 1"/>
+          <p:cNvSpPr txBox="1"/>
+          <p:nvPr/>
+        </p:nvSpPr>
+        <p:spPr>
+          <a:xfrm>
+            <a:off x="502920" y="256032"/>
+            <a:ext cx="8321040" cy="420624"/>
+          </a:xfrm>
+          <a:prstGeom prst="rect">
+            <a:avLst/>
+          </a:prstGeom>
+          <a:noFill/>
+        </p:spPr>
+        <p:txBody>
+          <a:bodyPr wrap="square" lIns="73152" rIns="73152">
+            <a:spAutoFit/>
+          </a:bodyPr>
+          <a:lstStyle/>
+          <a:p>
+            <a:r>
+              <a:rPr sz="2400" b="1">
+                <a:solidFill>
+                  <a:srgbClr val="1B2733"/>
+                </a:solidFill>
+              </a:rPr>
+              <a:t>Interpretation patterns and common mistakes</a:t>
+            </a:r>
+          </a:p>
+        </p:txBody>
+      </p:sp>
+      <p:sp>
+        <p:nvSpPr>
+          <p:cNvPr id="3" name="TextBox 2"/>
+          <p:cNvSpPr txBox="1"/>
+          <p:nvPr/>
+        </p:nvSpPr>
+        <p:spPr>
+          <a:xfrm>
+            <a:off x="521207" y="713232"/>
+            <a:ext cx="7772400" cy="237744"/>
+          </a:xfrm>
+          <a:prstGeom prst="rect">
+            <a:avLst/>
+          </a:prstGeom>
+          <a:noFill/>
+        </p:spPr>
+        <p:txBody>
+          <a:bodyPr wrap="square" lIns="73152" rIns="73152">
+            <a:spAutoFit/>
+          </a:bodyPr>
+          <a:lstStyle/>
+          <a:p>
+            <a:r>
+              <a:rPr sz="1100" b="0">
+                <a:solidFill>
+                  <a:srgbClr val="5A636C"/>
+                </a:solidFill>
+              </a:rPr>
+              <a:t>Fishbone Diagram</a:t>
+            </a:r>
+          </a:p>
+        </p:txBody>
+      </p:sp>
+      <p:sp>
+        <p:nvSpPr>
+          <p:cNvPr id="4" name="Rectangle 3"/>
+          <p:cNvSpPr/>
+          <p:nvPr/>
+        </p:nvSpPr>
+        <p:spPr>
+          <a:xfrm>
+            <a:off x="502920" y="941832"/>
+            <a:ext cx="11155680" cy="27432"/>
+          </a:xfrm>
+          <a:prstGeom prst="rect">
+            <a:avLst/>
+          </a:prstGeom>
+          <a:solidFill>
+            <a:srgbClr val="427E78"/>
+          </a:solidFill>
+          <a:ln>
+            <a:noFill/>
+          </a:ln>
+        </p:spPr>
+        <p:style>
+          <a:lnRef idx="1">
+            <a:schemeClr val="accent1"/>
+          </a:lnRef>
+          <a:fillRef idx="3">
+            <a:schemeClr val="accent1"/>
+          </a:fillRef>
+          <a:effectRef idx="2">
+            <a:schemeClr val="accent1"/>
+          </a:effectRef>
+          <a:fontRef idx="minor">
+            <a:schemeClr val="lt1"/>
+          </a:fontRef>
+        </p:style>
+        <p:txBody>
+          <a:bodyPr rtlCol="0" anchor="ctr"/>
+          <a:lstStyle/>
+          <a:p>
+            <a:pPr algn="ctr"/>
+          </a:p>
+        </p:txBody>
+      </p:sp>
+      <p:sp>
+        <p:nvSpPr>
+          <p:cNvPr id="5" name="Rounded Rectangle 4"/>
+          <p:cNvSpPr/>
+          <p:nvPr/>
+        </p:nvSpPr>
+        <p:spPr>
+          <a:xfrm>
+            <a:off x="640080" y="1325880"/>
+            <a:ext cx="5212080" cy="4526280"/>
+          </a:xfrm>
+          <a:prstGeom prst="roundRect">
+            <a:avLst/>
+          </a:prstGeom>
+          <a:solidFill>
+            <a:srgbClr val="F8F9F7"/>
+          </a:solidFill>
+          <a:ln>
+            <a:solidFill>
+              <a:srgbClr val="BEC4BF"/>
+            </a:solidFill>
+          </a:ln>
+        </p:spPr>
+        <p:style>
+          <a:lnRef idx="1">
+            <a:schemeClr val="accent1"/>
+          </a:lnRef>
+          <a:fillRef idx="3">
+            <a:schemeClr val="accent1"/>
+          </a:fillRef>
+          <a:effectRef idx="2">
+            <a:schemeClr val="accent1"/>
+          </a:effectRef>
+          <a:fontRef idx="minor">
+            <a:schemeClr val="lt1"/>
+          </a:fontRef>
+        </p:style>
+        <p:txBody>
+          <a:bodyPr rtlCol="0" anchor="t" lIns="164592" rIns="164592" tIns="128016"/>
+          <a:lstStyle/>
+          <a:p>
+            <a:pPr algn="ctr"/>
+            <a:r>
+              <a:rPr b="1" sz="1500">
+                <a:solidFill>
+                  <a:srgbClr val="1B2733"/>
+                </a:solidFill>
+              </a:rPr>
+              <a:t>Interpretation patterns</a:t>
+            </a:r>
+          </a:p>
+          <a:p>
+            <a:pPr>
+              <a:defRPr sz="1100">
+                <a:solidFill>
+                  <a:srgbClr val="2D3741"/>
+                </a:solidFill>
+              </a:defRPr>
+            </a:pPr>
+            <a:r>
+              <a:t>Cause map: name the highest-priority branches.</a:t>
+            </a:r>
+          </a:p>
+          <a:p>
+            <a:pPr>
+              <a:defRPr sz="1100">
+                <a:solidFill>
+                  <a:srgbClr val="2D3741"/>
+                </a:solidFill>
+              </a:defRPr>
+            </a:pPr>
+            <a:r>
+              <a:t>Verification decision: list causes to test next.</a:t>
+            </a:r>
+          </a:p>
+          <a:p>
+            <a:pPr>
+              <a:defRPr sz="1100">
+                <a:solidFill>
+                  <a:srgbClr val="2D3741"/>
+                </a:solidFill>
+              </a:defRPr>
+            </a:pPr>
+            <a:r>
+              <a:t>Next action: run 5 Whys or data checks for selected causes.</a:t>
+            </a:r>
+          </a:p>
+          <a:p>
+            <a:pPr>
+              <a:defRPr sz="1100">
+                <a:solidFill>
+                  <a:srgbClr val="2D3741"/>
+                </a:solidFill>
+              </a:defRPr>
+            </a:pPr>
+            <a:r>
+              <a:t>Caution: suspected causes remain unverified until tested.</a:t>
+            </a:r>
+          </a:p>
+        </p:txBody>
+      </p:sp>
+      <p:sp>
+        <p:nvSpPr>
+          <p:cNvPr id="6" name="Rounded Rectangle 5"/>
+          <p:cNvSpPr/>
+          <p:nvPr/>
+        </p:nvSpPr>
+        <p:spPr>
+          <a:xfrm>
+            <a:off x="6263640" y="1325880"/>
+            <a:ext cx="5212080" cy="4526280"/>
+          </a:xfrm>
+          <a:prstGeom prst="roundRect">
+            <a:avLst/>
+          </a:prstGeom>
+          <a:solidFill>
+            <a:srgbClr val="F8F9F7"/>
+          </a:solidFill>
+          <a:ln>
+            <a:solidFill>
+              <a:srgbClr val="BEC4BF"/>
+            </a:solidFill>
+          </a:ln>
+        </p:spPr>
+        <p:style>
+          <a:lnRef idx="1">
+            <a:schemeClr val="accent1"/>
+          </a:lnRef>
+          <a:fillRef idx="3">
+            <a:schemeClr val="accent1"/>
+          </a:fillRef>
+          <a:effectRef idx="2">
+            <a:schemeClr val="accent1"/>
+          </a:effectRef>
+          <a:fontRef idx="minor">
+            <a:schemeClr val="lt1"/>
+          </a:fontRef>
+        </p:style>
+        <p:txBody>
+          <a:bodyPr rtlCol="0" anchor="t" lIns="164592" rIns="164592" tIns="128016"/>
+          <a:lstStyle/>
+          <a:p>
+            <a:pPr algn="ctr"/>
+            <a:r>
+              <a:rPr b="1" sz="1500">
+                <a:solidFill>
+                  <a:srgbClr val="1B2733"/>
+                </a:solidFill>
+              </a:rPr>
+              <a:t>Common mistakes</a:t>
+            </a:r>
+          </a:p>
+          <a:p>
+            <a:pPr>
+              <a:defRPr sz="1100">
+                <a:solidFill>
+                  <a:srgbClr val="2D3741"/>
+                </a:solidFill>
+              </a:defRPr>
+            </a:pPr>
+            <a:r>
+              <a:t>Mixing several effects on one diagram.</a:t>
+            </a:r>
+          </a:p>
+          <a:p>
+            <a:pPr>
+              <a:defRPr sz="1100">
+                <a:solidFill>
+                  <a:srgbClr val="2D3741"/>
+                </a:solidFill>
+              </a:defRPr>
+            </a:pPr>
+            <a:r>
+              <a:t>Listing symptoms as causes.</a:t>
+            </a:r>
+          </a:p>
+          <a:p>
+            <a:pPr>
+              <a:defRPr sz="1100">
+                <a:solidFill>
+                  <a:srgbClr val="2D3741"/>
+                </a:solidFill>
+              </a:defRPr>
+            </a:pPr>
+            <a:r>
+              <a:t>Marking causes verified without evidence.</a:t>
+            </a:r>
+          </a:p>
+          <a:p>
+            <a:pPr>
+              <a:defRPr sz="1100">
+                <a:solidFill>
+                  <a:srgbClr val="2D3741"/>
+                </a:solidFill>
+              </a:defRPr>
+            </a:pPr>
+            <a:r>
+              <a:t>Treating demo content as project evidence.</a:t>
+            </a:r>
+          </a:p>
+        </p:txBody>
+      </p:sp>
+      <p:sp>
+        <p:nvSpPr>
+          <p:cNvPr id="7" name="TextBox 6"/>
+          <p:cNvSpPr txBox="1"/>
+          <p:nvPr/>
+        </p:nvSpPr>
+        <p:spPr>
+          <a:xfrm>
+            <a:off x="548640" y="6355080"/>
+            <a:ext cx="10881360" cy="228600"/>
+          </a:xfrm>
+          <a:prstGeom prst="rect">
+            <a:avLst/>
+          </a:prstGeom>
+          <a:noFill/>
+        </p:spPr>
+        <p:txBody>
+          <a:bodyPr wrap="square" lIns="73152" rIns="73152">
+            <a:spAutoFit/>
+          </a:bodyPr>
+          <a:lstStyle/>
+          <a:p>
+            <a:r>
+              <a:rPr sz="800" b="0">
+                <a:solidFill>
+                  <a:srgbClr val="697077"/>
+                </a:solidFill>
+              </a:rPr>
+              <a:t>fishbone_diagram_method_template | fishbone_diagram | Final data-dependent evidence belongs in the evidence package.</a:t>
+            </a:r>
+          </a:p>
+        </p:txBody>
+      </p:sp>
+    </p:spTree>
+  </p:cSld>
+  <p:clrMapOvr>
+    <a:masterClrMapping/>
+  </p:clrMapOvr>
+</p:sld>
+</file>
+
+<file path=ppt/slides/slide11.xml><?xml version="1.0" encoding="utf-8"?>
+<p:sld xmlns:a="http://schemas.openxmlformats.org/drawingml/2006/main" xmlns:p="http://schemas.openxmlformats.org/presentationml/2006/main" xmlns:r="http://schemas.openxmlformats.org/officeDocument/2006/relationships">
+  <p:cSld>
+    <p:spTree>
+      <p:nvGrpSpPr>
+        <p:cNvPr id="1" name=""/>
+        <p:cNvGrpSpPr/>
+        <p:nvPr/>
+      </p:nvGrpSpPr>
+      <p:grpSpPr/>
+      <p:sp>
+        <p:nvSpPr>
+          <p:cNvPr id="2" name="TextBox 1"/>
+          <p:cNvSpPr txBox="1"/>
+          <p:nvPr/>
+        </p:nvSpPr>
+        <p:spPr>
+          <a:xfrm>
+            <a:off x="502920" y="256032"/>
+            <a:ext cx="8321040" cy="420624"/>
+          </a:xfrm>
+          <a:prstGeom prst="rect">
+            <a:avLst/>
+          </a:prstGeom>
+          <a:noFill/>
+        </p:spPr>
+        <p:txBody>
+          <a:bodyPr wrap="square" lIns="73152" rIns="73152">
+            <a:spAutoFit/>
+          </a:bodyPr>
+          <a:lstStyle/>
+          <a:p>
+            <a:r>
+              <a:rPr sz="2400" b="1">
+                <a:solidFill>
+                  <a:srgbClr val="1B2733"/>
+                </a:solidFill>
+              </a:rPr>
+              <a:t>Facilitator checklist and Python assist decision</a:t>
+            </a:r>
+          </a:p>
+        </p:txBody>
+      </p:sp>
+      <p:sp>
+        <p:nvSpPr>
+          <p:cNvPr id="3" name="TextBox 2"/>
+          <p:cNvSpPr txBox="1"/>
+          <p:nvPr/>
+        </p:nvSpPr>
+        <p:spPr>
+          <a:xfrm>
+            <a:off x="521207" y="713232"/>
+            <a:ext cx="7772400" cy="237744"/>
+          </a:xfrm>
+          <a:prstGeom prst="rect">
+            <a:avLst/>
+          </a:prstGeom>
+          <a:noFill/>
+        </p:spPr>
+        <p:txBody>
+          <a:bodyPr wrap="square" lIns="73152" rIns="73152">
+            <a:spAutoFit/>
+          </a:bodyPr>
+          <a:lstStyle/>
+          <a:p>
+            <a:r>
+              <a:rPr sz="1100" b="0">
+                <a:solidFill>
+                  <a:srgbClr val="5A636C"/>
+                </a:solidFill>
+              </a:rPr>
+              <a:t>Fishbone Diagram</a:t>
+            </a:r>
+          </a:p>
+        </p:txBody>
+      </p:sp>
+      <p:sp>
+        <p:nvSpPr>
+          <p:cNvPr id="4" name="Rectangle 3"/>
+          <p:cNvSpPr/>
+          <p:nvPr/>
+        </p:nvSpPr>
+        <p:spPr>
+          <a:xfrm>
+            <a:off x="502920" y="941832"/>
+            <a:ext cx="11155680" cy="27432"/>
+          </a:xfrm>
+          <a:prstGeom prst="rect">
+            <a:avLst/>
+          </a:prstGeom>
+          <a:solidFill>
+            <a:srgbClr val="427E78"/>
+          </a:solidFill>
+          <a:ln>
+            <a:noFill/>
+          </a:ln>
+        </p:spPr>
+        <p:style>
+          <a:lnRef idx="1">
+            <a:schemeClr val="accent1"/>
+          </a:lnRef>
+          <a:fillRef idx="3">
+            <a:schemeClr val="accent1"/>
+          </a:fillRef>
+          <a:effectRef idx="2">
+            <a:schemeClr val="accent1"/>
+          </a:effectRef>
+          <a:fontRef idx="minor">
+            <a:schemeClr val="lt1"/>
+          </a:fontRef>
+        </p:style>
+        <p:txBody>
+          <a:bodyPr rtlCol="0" anchor="ctr"/>
+          <a:lstStyle/>
+          <a:p>
+            <a:pPr algn="ctr"/>
+          </a:p>
+        </p:txBody>
+      </p:sp>
+      <p:sp>
+        <p:nvSpPr>
+          <p:cNvPr id="5" name="Rounded Rectangle 4"/>
+          <p:cNvSpPr/>
+          <p:nvPr/>
+        </p:nvSpPr>
+        <p:spPr>
+          <a:xfrm>
+            <a:off x="640080" y="1325880"/>
+            <a:ext cx="5212080" cy="4526280"/>
+          </a:xfrm>
+          <a:prstGeom prst="roundRect">
+            <a:avLst/>
+          </a:prstGeom>
+          <a:solidFill>
+            <a:srgbClr val="F8F9F7"/>
+          </a:solidFill>
+          <a:ln>
+            <a:solidFill>
+              <a:srgbClr val="BEC4BF"/>
+            </a:solidFill>
+          </a:ln>
+        </p:spPr>
+        <p:style>
+          <a:lnRef idx="1">
+            <a:schemeClr val="accent1"/>
+          </a:lnRef>
+          <a:fillRef idx="3">
+            <a:schemeClr val="accent1"/>
+          </a:fillRef>
+          <a:effectRef idx="2">
+            <a:schemeClr val="accent1"/>
+          </a:effectRef>
+          <a:fontRef idx="minor">
+            <a:schemeClr val="lt1"/>
+          </a:fontRef>
+        </p:style>
+        <p:txBody>
+          <a:bodyPr rtlCol="0" anchor="t" lIns="164592" rIns="164592" tIns="128016"/>
+          <a:lstStyle/>
+          <a:p>
+            <a:pPr algn="ctr"/>
+            <a:r>
+              <a:rPr b="1" sz="1500">
+                <a:solidFill>
+                  <a:srgbClr val="1B2733"/>
+                </a:solidFill>
+              </a:rPr>
+              <a:t>Facilitator checklist</a:t>
+            </a:r>
+          </a:p>
+          <a:p>
+            <a:pPr>
+              <a:defRPr sz="1100">
+                <a:solidFill>
+                  <a:srgbClr val="2D3741"/>
+                </a:solidFill>
+              </a:defRPr>
+            </a:pPr>
+            <a:r>
+              <a:t>Effect statement matches project evidence.</a:t>
+            </a:r>
+          </a:p>
+          <a:p>
+            <a:pPr>
+              <a:defRPr sz="1100">
+                <a:solidFill>
+                  <a:srgbClr val="2D3741"/>
+                </a:solidFill>
+              </a:defRPr>
+            </a:pPr>
+            <a:r>
+              <a:t>Source and date range or session date shown.</a:t>
+            </a:r>
+          </a:p>
+          <a:p>
+            <a:pPr>
+              <a:defRPr sz="1100">
+                <a:solidFill>
+                  <a:srgbClr val="2D3741"/>
+                </a:solidFill>
+              </a:defRPr>
+            </a:pPr>
+            <a:r>
+              <a:t>Suspected and verified causes are separated.</a:t>
+            </a:r>
+          </a:p>
+          <a:p>
+            <a:pPr>
+              <a:defRPr sz="1100">
+                <a:solidFill>
+                  <a:srgbClr val="2D3741"/>
+                </a:solidFill>
+              </a:defRPr>
+            </a:pPr>
+            <a:r>
+              <a:t>Key conclusion and next action are written.</a:t>
+            </a:r>
+          </a:p>
+        </p:txBody>
+      </p:sp>
+      <p:sp>
+        <p:nvSpPr>
+          <p:cNvPr id="6" name="Rounded Rectangle 5"/>
+          <p:cNvSpPr/>
+          <p:nvPr/>
+        </p:nvSpPr>
+        <p:spPr>
+          <a:xfrm>
+            <a:off x="6263640" y="1325880"/>
+            <a:ext cx="5212080" cy="4526280"/>
+          </a:xfrm>
+          <a:prstGeom prst="roundRect">
+            <a:avLst/>
+          </a:prstGeom>
+          <a:solidFill>
+            <a:srgbClr val="F8F9F7"/>
+          </a:solidFill>
+          <a:ln>
+            <a:solidFill>
+              <a:srgbClr val="BEC4BF"/>
+            </a:solidFill>
+          </a:ln>
+        </p:spPr>
+        <p:style>
+          <a:lnRef idx="1">
+            <a:schemeClr val="accent1"/>
+          </a:lnRef>
+          <a:fillRef idx="3">
+            <a:schemeClr val="accent1"/>
+          </a:fillRef>
+          <a:effectRef idx="2">
+            <a:schemeClr val="accent1"/>
+          </a:effectRef>
+          <a:fontRef idx="minor">
+            <a:schemeClr val="lt1"/>
+          </a:fontRef>
+        </p:style>
+        <p:txBody>
+          <a:bodyPr rtlCol="0" anchor="t" lIns="164592" rIns="164592" tIns="128016"/>
+          <a:lstStyle/>
+          <a:p>
+            <a:pPr algn="ctr"/>
+            <a:r>
+              <a:rPr b="1" sz="1500">
+                <a:solidFill>
+                  <a:srgbClr val="1B2733"/>
+                </a:solidFill>
+              </a:rPr>
+              <a:t>Python assist decision</a:t>
+            </a:r>
+          </a:p>
+          <a:p>
+            <a:pPr>
+              <a:defRPr sz="1100">
+                <a:solidFill>
+                  <a:srgbClr val="2D3741"/>
+                </a:solidFill>
+              </a:defRPr>
+            </a:pPr>
+            <a:r>
+              <a:t>PowerPoint is enough for teaching, draft, and diagram editing.</a:t>
+            </a:r>
+          </a:p>
+          <a:p>
+            <a:pPr>
+              <a:defRPr sz="1100">
+                <a:solidFill>
+                  <a:srgbClr val="2D3741"/>
+                </a:solidFill>
+              </a:defRPr>
+            </a:pPr>
+            <a:r>
+              <a:t>Python is not normally needed for this visual method.</a:t>
+            </a:r>
+          </a:p>
+          <a:p>
+            <a:pPr>
+              <a:defRPr sz="1100">
+                <a:solidFill>
+                  <a:srgbClr val="2D3741"/>
+                </a:solidFill>
+              </a:defRPr>
+            </a:pPr>
+            <a:r>
+              <a:t>Use Python later only to summarize verification data.</a:t>
+            </a:r>
+          </a:p>
+          <a:p>
+            <a:pPr>
+              <a:defRPr sz="1100">
+                <a:solidFill>
+                  <a:srgbClr val="2D3741"/>
+                </a:solidFill>
+              </a:defRPr>
+            </a:pPr>
+            <a:r>
+              <a:t>High-rigor data claims need a validated path.</a:t>
+            </a:r>
+          </a:p>
+        </p:txBody>
+      </p:sp>
+      <p:sp>
+        <p:nvSpPr>
+          <p:cNvPr id="7" name="TextBox 6"/>
+          <p:cNvSpPr txBox="1"/>
+          <p:nvPr/>
+        </p:nvSpPr>
+        <p:spPr>
+          <a:xfrm>
+            <a:off x="548640" y="6355080"/>
+            <a:ext cx="10881360" cy="228600"/>
+          </a:xfrm>
+          <a:prstGeom prst="rect">
+            <a:avLst/>
+          </a:prstGeom>
+          <a:noFill/>
+        </p:spPr>
+        <p:txBody>
+          <a:bodyPr wrap="square" lIns="73152" rIns="73152">
+            <a:spAutoFit/>
+          </a:bodyPr>
+          <a:lstStyle/>
+          <a:p>
+            <a:r>
+              <a:rPr sz="800" b="0">
+                <a:solidFill>
+                  <a:srgbClr val="697077"/>
+                </a:solidFill>
+              </a:rPr>
+              <a:t>fishbone_diagram_method_template | fishbone_diagram | Final data-dependent evidence belongs in the evidence package.</a:t>
+            </a:r>
+          </a:p>
+        </p:txBody>
+      </p:sp>
+    </p:spTree>
+  </p:cSld>
+  <p:clrMapOvr>
+    <a:masterClrMapping/>
+  </p:clrMapOvr>
+</p:sld>
+</file>
+
+<file path=ppt/slides/slide12.xml><?xml version="1.0" encoding="utf-8"?>
+<p:sld xmlns:a="http://schemas.openxmlformats.org/drawingml/2006/main" xmlns:p="http://schemas.openxmlformats.org/presentationml/2006/main" xmlns:r="http://schemas.openxmlformats.org/officeDocument/2006/relationships">
+  <p:cSld>
+    <p:spTree>
+      <p:nvGrpSpPr>
+        <p:cNvPr id="1" name=""/>
+        <p:cNvGrpSpPr/>
+        <p:nvPr/>
+      </p:nvGrpSpPr>
+      <p:grpSpPr/>
+      <p:sp>
+        <p:nvSpPr>
+          <p:cNvPr id="2" name="TextBox 1"/>
+          <p:cNvSpPr txBox="1"/>
+          <p:nvPr/>
+        </p:nvSpPr>
+        <p:spPr>
+          <a:xfrm>
+            <a:off x="502920" y="256032"/>
+            <a:ext cx="8321040" cy="420624"/>
+          </a:xfrm>
+          <a:prstGeom prst="rect">
+            <a:avLst/>
+          </a:prstGeom>
+          <a:noFill/>
+        </p:spPr>
+        <p:txBody>
+          <a:bodyPr wrap="square" lIns="73152" rIns="73152">
+            <a:spAutoFit/>
+          </a:bodyPr>
+          <a:lstStyle/>
+          <a:p>
+            <a:r>
+              <a:rPr sz="2400" b="1">
+                <a:solidFill>
+                  <a:srgbClr val="1B2733"/>
+                </a:solidFill>
+              </a:rPr>
+              <a:t>Evidence/source note</a:t>
+            </a:r>
+          </a:p>
+        </p:txBody>
+      </p:sp>
+      <p:sp>
+        <p:nvSpPr>
+          <p:cNvPr id="3" name="TextBox 2"/>
+          <p:cNvSpPr txBox="1"/>
+          <p:nvPr/>
+        </p:nvSpPr>
+        <p:spPr>
+          <a:xfrm>
+            <a:off x="521207" y="713232"/>
+            <a:ext cx="7772400" cy="237744"/>
+          </a:xfrm>
+          <a:prstGeom prst="rect">
+            <a:avLst/>
+          </a:prstGeom>
+          <a:noFill/>
+        </p:spPr>
+        <p:txBody>
+          <a:bodyPr wrap="square" lIns="73152" rIns="73152">
+            <a:spAutoFit/>
+          </a:bodyPr>
+          <a:lstStyle/>
+          <a:p>
+            <a:r>
+              <a:rPr sz="1100" b="0">
+                <a:solidFill>
+                  <a:srgbClr val="5A636C"/>
+                </a:solidFill>
+              </a:rPr>
+              <a:t>Fishbone Diagram</a:t>
+            </a:r>
+          </a:p>
+        </p:txBody>
+      </p:sp>
+      <p:sp>
+        <p:nvSpPr>
+          <p:cNvPr id="4" name="Rectangle 3"/>
+          <p:cNvSpPr/>
+          <p:nvPr/>
+        </p:nvSpPr>
+        <p:spPr>
+          <a:xfrm>
+            <a:off x="502920" y="941832"/>
+            <a:ext cx="11155680" cy="27432"/>
+          </a:xfrm>
+          <a:prstGeom prst="rect">
+            <a:avLst/>
+          </a:prstGeom>
+          <a:solidFill>
+            <a:srgbClr val="427E78"/>
+          </a:solidFill>
+          <a:ln>
+            <a:noFill/>
+          </a:ln>
+        </p:spPr>
+        <p:style>
+          <a:lnRef idx="1">
+            <a:schemeClr val="accent1"/>
+          </a:lnRef>
+          <a:fillRef idx="3">
+            <a:schemeClr val="accent1"/>
+          </a:fillRef>
+          <a:effectRef idx="2">
+            <a:schemeClr val="accent1"/>
+          </a:effectRef>
+          <a:fontRef idx="minor">
+            <a:schemeClr val="lt1"/>
+          </a:fontRef>
+        </p:style>
+        <p:txBody>
+          <a:bodyPr rtlCol="0" anchor="ctr"/>
+          <a:lstStyle/>
+          <a:p>
+            <a:pPr algn="ctr"/>
+          </a:p>
+        </p:txBody>
+      </p:sp>
+      <p:sp>
+        <p:nvSpPr>
+          <p:cNvPr id="5" name="Rounded Rectangle 4"/>
+          <p:cNvSpPr/>
+          <p:nvPr/>
+        </p:nvSpPr>
+        <p:spPr>
+          <a:xfrm>
+            <a:off x="640080" y="1325880"/>
+            <a:ext cx="5212080" cy="4526280"/>
+          </a:xfrm>
+          <a:prstGeom prst="roundRect">
+            <a:avLst/>
+          </a:prstGeom>
+          <a:solidFill>
+            <a:srgbClr val="F8F9F7"/>
+          </a:solidFill>
+          <a:ln>
+            <a:solidFill>
+              <a:srgbClr val="BEC4BF"/>
+            </a:solidFill>
+          </a:ln>
+        </p:spPr>
+        <p:style>
+          <a:lnRef idx="1">
+            <a:schemeClr val="accent1"/>
+          </a:lnRef>
+          <a:fillRef idx="3">
+            <a:schemeClr val="accent1"/>
+          </a:fillRef>
+          <a:effectRef idx="2">
+            <a:schemeClr val="accent1"/>
+          </a:effectRef>
+          <a:fontRef idx="minor">
+            <a:schemeClr val="lt1"/>
+          </a:fontRef>
+        </p:style>
+        <p:txBody>
+          <a:bodyPr rtlCol="0" anchor="t" lIns="164592" rIns="164592" tIns="128016"/>
+          <a:lstStyle/>
+          <a:p>
+            <a:pPr algn="ctr"/>
+            <a:r>
+              <a:rPr b="1" sz="1500">
+                <a:solidFill>
+                  <a:srgbClr val="1B2733"/>
+                </a:solidFill>
+              </a:rPr>
+              <a:t>Evidence levels</a:t>
+            </a:r>
+          </a:p>
+          <a:p>
+            <a:pPr>
+              <a:defRPr sz="1100">
+                <a:solidFill>
+                  <a:srgbClr val="2D3741"/>
+                </a:solidFill>
+              </a:defRPr>
+            </a:pPr>
+            <a:r>
+              <a:t>Level 1: teaching/draft PowerPoint edits.</a:t>
+            </a:r>
+          </a:p>
+          <a:p>
+            <a:pPr>
+              <a:defRPr sz="1100">
+                <a:solidFill>
+                  <a:srgbClr val="2D3741"/>
+                </a:solidFill>
+              </a:defRPr>
+            </a:pPr>
+            <a:r>
+              <a:t>Level 2: normal project with source and checklist evidence.</a:t>
+            </a:r>
+          </a:p>
+          <a:p>
+            <a:pPr>
+              <a:defRPr sz="1100">
+                <a:solidFill>
+                  <a:srgbClr val="2D3741"/>
+                </a:solidFill>
+              </a:defRPr>
+            </a:pPr>
+            <a:r>
+              <a:t>Level 3: formal review with source data and versioned template.</a:t>
+            </a:r>
+          </a:p>
+          <a:p>
+            <a:pPr>
+              <a:defRPr sz="1100">
+                <a:solidFill>
+                  <a:srgbClr val="2D3741"/>
+                </a:solidFill>
+              </a:defRPr>
+            </a:pPr>
+            <a:r>
+              <a:t>Level 4: audit/high-risk reproducible evidence.</a:t>
+            </a:r>
+          </a:p>
+        </p:txBody>
+      </p:sp>
+      <p:sp>
+        <p:nvSpPr>
+          <p:cNvPr id="6" name="Rounded Rectangle 5"/>
+          <p:cNvSpPr/>
+          <p:nvPr/>
+        </p:nvSpPr>
+        <p:spPr>
+          <a:xfrm>
+            <a:off x="6263640" y="1325880"/>
+            <a:ext cx="5212080" cy="4526280"/>
+          </a:xfrm>
+          <a:prstGeom prst="roundRect">
+            <a:avLst/>
+          </a:prstGeom>
+          <a:solidFill>
+            <a:srgbClr val="F8F9F7"/>
+          </a:solidFill>
+          <a:ln>
+            <a:solidFill>
+              <a:srgbClr val="BEC4BF"/>
+            </a:solidFill>
+          </a:ln>
+        </p:spPr>
+        <p:style>
+          <a:lnRef idx="1">
+            <a:schemeClr val="accent1"/>
+          </a:lnRef>
+          <a:fillRef idx="3">
+            <a:schemeClr val="accent1"/>
+          </a:fillRef>
+          <a:effectRef idx="2">
+            <a:schemeClr val="accent1"/>
+          </a:effectRef>
+          <a:fontRef idx="minor">
+            <a:schemeClr val="lt1"/>
+          </a:fontRef>
+        </p:style>
+        <p:txBody>
+          <a:bodyPr rtlCol="0" anchor="t" lIns="164592" rIns="164592" tIns="128016"/>
+          <a:lstStyle/>
+          <a:p>
+            <a:pPr algn="ctr"/>
+            <a:r>
+              <a:rPr b="1" sz="1500">
+                <a:solidFill>
+                  <a:srgbClr val="1B2733"/>
+                </a:solidFill>
+              </a:rPr>
+              <a:t>Evidence/source note</a:t>
+            </a:r>
+          </a:p>
+          <a:p>
+            <a:pPr>
+              <a:defRPr sz="1100">
+                <a:solidFill>
+                  <a:srgbClr val="2D3741"/>
+                </a:solidFill>
+              </a:defRPr>
+            </a:pPr>
+            <a:r>
+              <a:t>Record source.</a:t>
+            </a:r>
+          </a:p>
+          <a:p>
+            <a:pPr>
+              <a:defRPr sz="1100">
+                <a:solidFill>
+                  <a:srgbClr val="2D3741"/>
+                </a:solidFill>
+              </a:defRPr>
+            </a:pPr>
+            <a:r>
+              <a:t>Record date range or session date.</a:t>
+            </a:r>
+          </a:p>
+          <a:p>
+            <a:pPr>
+              <a:defRPr sz="1100">
+                <a:solidFill>
+                  <a:srgbClr val="2D3741"/>
+                </a:solidFill>
+              </a:defRPr>
+            </a:pPr>
+            <a:r>
+              <a:t>Record assumptions and verification status.</a:t>
+            </a:r>
+          </a:p>
+          <a:p>
+            <a:pPr>
+              <a:defRPr sz="1100">
+                <a:solidFill>
+                  <a:srgbClr val="2D3741"/>
+                </a:solidFill>
+              </a:defRPr>
+            </a:pPr>
+            <a:r>
+              <a:t>Record prepared by/date.</a:t>
+            </a:r>
+          </a:p>
+        </p:txBody>
+      </p:sp>
+      <p:sp>
+        <p:nvSpPr>
+          <p:cNvPr id="7" name="TextBox 6"/>
+          <p:cNvSpPr txBox="1"/>
+          <p:nvPr/>
+        </p:nvSpPr>
+        <p:spPr>
+          <a:xfrm>
+            <a:off x="548640" y="6355080"/>
+            <a:ext cx="10881360" cy="228600"/>
+          </a:xfrm>
+          <a:prstGeom prst="rect">
+            <a:avLst/>
+          </a:prstGeom>
+          <a:noFill/>
+        </p:spPr>
+        <p:txBody>
+          <a:bodyPr wrap="square" lIns="73152" rIns="73152">
+            <a:spAutoFit/>
+          </a:bodyPr>
+          <a:lstStyle/>
+          <a:p>
+            <a:r>
+              <a:rPr sz="800" b="0">
+                <a:solidFill>
+                  <a:srgbClr val="697077"/>
+                </a:solidFill>
+              </a:rPr>
+              <a:t>fishbone_diagram_method_template | fishbone_diagram | Final data-dependent evidence belongs in the evidence package.</a:t>
+            </a:r>
+          </a:p>
+        </p:txBody>
+      </p:sp>
+    </p:spTree>
+  </p:cSld>
+  <p:clrMapOvr>
+    <a:masterClrMapping/>
+  </p:clrMapOvr>
+</p:sld>
+</file>
+
+<file path=ppt/slides/slide13.xml><?xml version="1.0" encoding="utf-8"?>
+<p:sld xmlns:a="http://schemas.openxmlformats.org/drawingml/2006/main" xmlns:p="http://schemas.openxmlformats.org/presentationml/2006/main" xmlns:r="http://schemas.openxmlformats.org/officeDocument/2006/relationships">
+  <p:cSld>
+    <p:spTree>
+      <p:nvGrpSpPr>
+        <p:cNvPr id="1" name=""/>
+        <p:cNvGrpSpPr/>
+        <p:nvPr/>
+      </p:nvGrpSpPr>
+      <p:grpSpPr/>
+      <p:sp>
+        <p:nvSpPr>
+          <p:cNvPr id="2" name="TextBox 1"/>
+          <p:cNvSpPr txBox="1"/>
+          <p:nvPr/>
+        </p:nvSpPr>
+        <p:spPr>
+          <a:xfrm>
+            <a:off x="502920" y="256032"/>
+            <a:ext cx="8321040" cy="420624"/>
+          </a:xfrm>
+          <a:prstGeom prst="rect">
+            <a:avLst/>
+          </a:prstGeom>
+          <a:noFill/>
+        </p:spPr>
+        <p:txBody>
+          <a:bodyPr wrap="square" lIns="73152" rIns="73152">
+            <a:spAutoFit/>
+          </a:bodyPr>
+          <a:lstStyle/>
+          <a:p>
+            <a:r>
+              <a:rPr sz="2400" b="1">
+                <a:solidFill>
+                  <a:srgbClr val="1B2733"/>
+                </a:solidFill>
+              </a:rPr>
+              <a:t>DEMO EXAMPLE - not project evidence</a:t>
+            </a:r>
+          </a:p>
+        </p:txBody>
+      </p:sp>
+      <p:sp>
+        <p:nvSpPr>
+          <p:cNvPr id="3" name="TextBox 2"/>
+          <p:cNvSpPr txBox="1"/>
+          <p:nvPr/>
+        </p:nvSpPr>
+        <p:spPr>
+          <a:xfrm>
+            <a:off x="521207" y="713232"/>
+            <a:ext cx="7772400" cy="237744"/>
+          </a:xfrm>
+          <a:prstGeom prst="rect">
+            <a:avLst/>
+          </a:prstGeom>
+          <a:noFill/>
+        </p:spPr>
+        <p:txBody>
+          <a:bodyPr wrap="square" lIns="73152" rIns="73152">
+            <a:spAutoFit/>
+          </a:bodyPr>
+          <a:lstStyle/>
+          <a:p>
+            <a:r>
+              <a:rPr sz="1100" b="0">
+                <a:solidFill>
+                  <a:srgbClr val="5A636C"/>
+                </a:solidFill>
+              </a:rPr>
+              <a:t>Fishbone Diagram</a:t>
+            </a:r>
+          </a:p>
+        </p:txBody>
+      </p:sp>
+      <p:sp>
+        <p:nvSpPr>
+          <p:cNvPr id="4" name="Rectangle 3"/>
+          <p:cNvSpPr/>
+          <p:nvPr/>
+        </p:nvSpPr>
+        <p:spPr>
+          <a:xfrm>
+            <a:off x="502920" y="941832"/>
+            <a:ext cx="11155680" cy="27432"/>
+          </a:xfrm>
+          <a:prstGeom prst="rect">
+            <a:avLst/>
+          </a:prstGeom>
+          <a:solidFill>
+            <a:srgbClr val="427E78"/>
+          </a:solidFill>
+          <a:ln>
+            <a:noFill/>
+          </a:ln>
+        </p:spPr>
+        <p:style>
+          <a:lnRef idx="1">
+            <a:schemeClr val="accent1"/>
+          </a:lnRef>
+          <a:fillRef idx="3">
+            <a:schemeClr val="accent1"/>
+          </a:fillRef>
+          <a:effectRef idx="2">
+            <a:schemeClr val="accent1"/>
+          </a:effectRef>
+          <a:fontRef idx="minor">
+            <a:schemeClr val="lt1"/>
+          </a:fontRef>
+        </p:style>
+        <p:txBody>
+          <a:bodyPr rtlCol="0" anchor="ctr"/>
+          <a:lstStyle/>
+          <a:p>
+            <a:pPr algn="ctr"/>
+          </a:p>
+        </p:txBody>
+      </p:sp>
+      <p:sp>
+        <p:nvSpPr>
+          <p:cNvPr id="5" name="Rounded Rectangle 4"/>
+          <p:cNvSpPr/>
+          <p:nvPr/>
+        </p:nvSpPr>
+        <p:spPr>
+          <a:xfrm>
+            <a:off x="640080" y="1051560"/>
+            <a:ext cx="3840480" cy="329184"/>
+          </a:xfrm>
+          <a:prstGeom prst="roundRect">
+            <a:avLst/>
+          </a:prstGeom>
+          <a:solidFill>
+            <a:srgbClr val="FFF2CC"/>
+          </a:solidFill>
+          <a:ln>
+            <a:solidFill>
+              <a:srgbClr val="D69F2E"/>
+            </a:solidFill>
+          </a:ln>
+        </p:spPr>
+        <p:style>
+          <a:lnRef idx="1">
+            <a:schemeClr val="accent1"/>
+          </a:lnRef>
+          <a:fillRef idx="3">
+            <a:schemeClr val="accent1"/>
+          </a:fillRef>
+          <a:effectRef idx="2">
+            <a:schemeClr val="accent1"/>
+          </a:effectRef>
+          <a:fontRef idx="minor">
+            <a:schemeClr val="lt1"/>
+          </a:fontRef>
+        </p:style>
+        <p:txBody>
+          <a:bodyPr rtlCol="0" anchor="ctr"/>
+          <a:lstStyle/>
+          <a:p>
+            <a:pPr algn="ctr"/>
+            <a:r>
+              <a:rPr b="1" sz="1100">
+                <a:solidFill>
+                  <a:srgbClr val="664B11"/>
+                </a:solidFill>
+              </a:rPr>
+              <a:t>DEMO EXAMPLE - not project evidence</a:t>
+            </a:r>
+          </a:p>
+        </p:txBody>
+      </p:sp>
+      <p:sp>
+        <p:nvSpPr>
+          <p:cNvPr id="6" name="Rounded Rectangle 5"/>
+          <p:cNvSpPr/>
+          <p:nvPr/>
+        </p:nvSpPr>
+        <p:spPr>
+          <a:xfrm>
+            <a:off x="640080" y="1691640"/>
+            <a:ext cx="5394960" cy="4206240"/>
+          </a:xfrm>
+          <a:prstGeom prst="roundRect">
+            <a:avLst/>
+          </a:prstGeom>
+          <a:solidFill>
+            <a:srgbClr val="F8F9F7"/>
+          </a:solidFill>
+          <a:ln>
+            <a:solidFill>
+              <a:srgbClr val="BEC4BF"/>
+            </a:solidFill>
+          </a:ln>
+        </p:spPr>
+        <p:style>
+          <a:lnRef idx="1">
+            <a:schemeClr val="accent1"/>
+          </a:lnRef>
+          <a:fillRef idx="3">
+            <a:schemeClr val="accent1"/>
+          </a:fillRef>
+          <a:effectRef idx="2">
+            <a:schemeClr val="accent1"/>
+          </a:effectRef>
+          <a:fontRef idx="minor">
+            <a:schemeClr val="lt1"/>
+          </a:fontRef>
+        </p:style>
+        <p:txBody>
+          <a:bodyPr rtlCol="0" anchor="t" lIns="164592" rIns="164592" tIns="128016"/>
+          <a:lstStyle/>
+          <a:p>
+            <a:pPr algn="ctr"/>
+            <a:r>
+              <a:rPr b="1" sz="1500">
+                <a:solidFill>
+                  <a:srgbClr val="1B2733"/>
+                </a:solidFill>
+              </a:rPr>
+              <a:t>Demo structure</a:t>
+            </a:r>
+          </a:p>
+          <a:p>
+            <a:pPr>
+              <a:defRPr sz="1100">
+                <a:solidFill>
+                  <a:srgbClr val="2D3741"/>
+                </a:solidFill>
+              </a:defRPr>
+            </a:pPr>
+            <a:r>
+              <a:t>Change data only: replace branch causes and evidence notes.</a:t>
+            </a:r>
+          </a:p>
+          <a:p>
+            <a:pPr>
+              <a:defRPr sz="1100">
+                <a:solidFill>
+                  <a:srgbClr val="2D3741"/>
+                </a:solidFill>
+              </a:defRPr>
+            </a:pPr>
+            <a:r>
+              <a:t>Effect statement: {{effect_statement}}</a:t>
+            </a:r>
+          </a:p>
+          <a:p>
+            <a:pPr>
+              <a:defRPr sz="1100">
+                <a:solidFill>
+                  <a:srgbClr val="2D3741"/>
+                </a:solidFill>
+              </a:defRPr>
+            </a:pPr>
+            <a:r>
+              <a:t>Cause branches: {{cause_branches}}</a:t>
+            </a:r>
+          </a:p>
+          <a:p>
+            <a:pPr>
+              <a:defRPr sz="1100">
+                <a:solidFill>
+                  <a:srgbClr val="2D3741"/>
+                </a:solidFill>
+              </a:defRPr>
+            </a:pPr>
+            <a:r>
+              <a:t>Verified causes: {{verified_causes}}</a:t>
+            </a:r>
+          </a:p>
+        </p:txBody>
+      </p:sp>
+      <p:sp>
+        <p:nvSpPr>
+          <p:cNvPr id="7" name="Rounded Rectangle 6"/>
+          <p:cNvSpPr/>
+          <p:nvPr/>
+        </p:nvSpPr>
+        <p:spPr>
+          <a:xfrm>
+            <a:off x="6355080" y="1691640"/>
+            <a:ext cx="4892040" cy="4206240"/>
+          </a:xfrm>
+          <a:prstGeom prst="roundRect">
+            <a:avLst/>
+          </a:prstGeom>
+          <a:solidFill>
+            <a:srgbClr val="F8F9F7"/>
+          </a:solidFill>
+          <a:ln>
+            <a:solidFill>
+              <a:srgbClr val="BEC4BF"/>
+            </a:solidFill>
+          </a:ln>
+        </p:spPr>
+        <p:style>
+          <a:lnRef idx="1">
+            <a:schemeClr val="accent1"/>
+          </a:lnRef>
+          <a:fillRef idx="3">
+            <a:schemeClr val="accent1"/>
+          </a:fillRef>
+          <a:effectRef idx="2">
+            <a:schemeClr val="accent1"/>
+          </a:effectRef>
+          <a:fontRef idx="minor">
+            <a:schemeClr val="lt1"/>
+          </a:fontRef>
+        </p:style>
+        <p:txBody>
+          <a:bodyPr rtlCol="0" anchor="t" lIns="164592" rIns="164592" tIns="128016"/>
+          <a:lstStyle/>
+          <a:p>
+            <a:pPr algn="ctr"/>
+            <a:r>
+              <a:rPr b="1" sz="1500">
+                <a:solidFill>
+                  <a:srgbClr val="1B2733"/>
+                </a:solidFill>
+              </a:rPr>
+              <a:t>Reserved placeholders</a:t>
+            </a:r>
+          </a:p>
+          <a:p>
+            <a:pPr>
+              <a:defRPr sz="1100">
+                <a:solidFill>
+                  <a:srgbClr val="2D3741"/>
+                </a:solidFill>
+              </a:defRPr>
+            </a:pPr>
+            <a:r>
+              <a:t>{{method_name}}</a:t>
+            </a:r>
+          </a:p>
+          <a:p>
+            <a:pPr>
+              <a:defRPr sz="1100">
+                <a:solidFill>
+                  <a:srgbClr val="2D3741"/>
+                </a:solidFill>
+              </a:defRPr>
+            </a:pPr>
+            <a:r>
+              <a:t>{{qcc_stage}}</a:t>
+            </a:r>
+          </a:p>
+          <a:p>
+            <a:pPr>
+              <a:defRPr sz="1100">
+                <a:solidFill>
+                  <a:srgbClr val="2D3741"/>
+                </a:solidFill>
+              </a:defRPr>
+            </a:pPr>
+            <a:r>
+              <a:t>{{demo_label}}</a:t>
+            </a:r>
+          </a:p>
+          <a:p>
+            <a:pPr>
+              <a:defRPr sz="1100">
+                <a:solidFill>
+                  <a:srgbClr val="2D3741"/>
+                </a:solidFill>
+              </a:defRPr>
+            </a:pPr>
+            <a:r>
+              <a:t>{{effect_statement}}</a:t>
+            </a:r>
+          </a:p>
+          <a:p>
+            <a:pPr>
+              <a:defRPr sz="1100">
+                <a:solidFill>
+                  <a:srgbClr val="2D3741"/>
+                </a:solidFill>
+              </a:defRPr>
+            </a:pPr>
+            <a:r>
+              <a:t>{{cause_branches}}</a:t>
+            </a:r>
+          </a:p>
+          <a:p>
+            <a:pPr>
+              <a:defRPr sz="1100">
+                <a:solidFill>
+                  <a:srgbClr val="2D3741"/>
+                </a:solidFill>
+              </a:defRPr>
+            </a:pPr>
+            <a:r>
+              <a:t>{{verified_causes}}</a:t>
+            </a:r>
+          </a:p>
+        </p:txBody>
+      </p:sp>
+      <p:sp>
+        <p:nvSpPr>
+          <p:cNvPr id="8" name="TextBox 7"/>
+          <p:cNvSpPr txBox="1"/>
+          <p:nvPr/>
+        </p:nvSpPr>
+        <p:spPr>
+          <a:xfrm>
+            <a:off x="548640" y="6355080"/>
+            <a:ext cx="10881360" cy="228600"/>
+          </a:xfrm>
+          <a:prstGeom prst="rect">
+            <a:avLst/>
+          </a:prstGeom>
+          <a:noFill/>
+        </p:spPr>
+        <p:txBody>
+          <a:bodyPr wrap="square" lIns="73152" rIns="73152">
+            <a:spAutoFit/>
+          </a:bodyPr>
+          <a:lstStyle/>
+          <a:p>
+            <a:r>
+              <a:rPr sz="800" b="0">
+                <a:solidFill>
+                  <a:srgbClr val="697077"/>
+                </a:solidFill>
+              </a:rPr>
+              <a:t>fishbone_diagram_method_template | fishbone_diagram | Final data-dependent evidence belongs in the evidence package.</a:t>
+            </a:r>
+          </a:p>
+        </p:txBody>
+      </p:sp>
+    </p:spTree>
+  </p:cSld>
+  <p:clrMapOvr>
+    <a:masterClrMapping/>
+  </p:clrMapOvr>
+</p:sld>
+</file>
+
+<file path=ppt/slides/slide14.xml><?xml version="1.0" encoding="utf-8"?>
 <p:sld xmlns:a="http://schemas.openxmlformats.org/drawingml/2006/main" xmlns:p="http://schemas.openxmlformats.org/presentationml/2006/main" xmlns:r="http://schemas.openxmlformats.org/officeDocument/2006/relationships">
   <p:cSld>
     <p:spTree>
@@ -5879,7 +7408,7 @@
                   <a:srgbClr val="1B2733"/>
                 </a:solidFill>
               </a:rPr>
-              <a:t>Interpretation patterns and common mistakes</a:t>
+              <a:t>Diagram quality guide</a:t>
             </a:r>
           </a:p>
         </p:txBody>
@@ -6008,55 +7537,55 @@
                   <a:srgbClr val="1B2733"/>
                 </a:solidFill>
               </a:rPr>
-              <a:t>Interpretation patterns</a:t>
-            </a:r>
-          </a:p>
-          <a:p>
-            <a:pPr>
-              <a:defRPr sz="1100">
-                <a:solidFill>
-                  <a:srgbClr val="2D3741"/>
-                </a:solidFill>
-              </a:defRPr>
-            </a:pPr>
-            <a:r>
-              <a:t>Cause map: name the highest-priority branches.</a:t>
-            </a:r>
-          </a:p>
-          <a:p>
-            <a:pPr>
-              <a:defRPr sz="1100">
-                <a:solidFill>
-                  <a:srgbClr val="2D3741"/>
-                </a:solidFill>
-              </a:defRPr>
-            </a:pPr>
-            <a:r>
-              <a:t>Verification decision: list causes to test next.</a:t>
-            </a:r>
-          </a:p>
-          <a:p>
-            <a:pPr>
-              <a:defRPr sz="1100">
-                <a:solidFill>
-                  <a:srgbClr val="2D3741"/>
-                </a:solidFill>
-              </a:defRPr>
-            </a:pPr>
-            <a:r>
-              <a:t>Next action: run 5 Whys or data checks for selected causes.</a:t>
-            </a:r>
-          </a:p>
-          <a:p>
-            <a:pPr>
-              <a:defRPr sz="1100">
-                <a:solidFill>
-                  <a:srgbClr val="2D3741"/>
-                </a:solidFill>
-              </a:defRPr>
-            </a:pPr>
-            <a:r>
-              <a:t>Caution: suspected causes remain unverified until tested.</a:t>
+              <a:t>Diagram decision</a:t>
+            </a:r>
+          </a:p>
+          <a:p>
+            <a:pPr>
+              <a:defRPr sz="1100">
+                <a:solidFill>
+                  <a:srgbClr val="2D3741"/>
+                </a:solidFill>
+              </a:defRPr>
+            </a:pPr>
+            <a:r>
+              <a:t>Select suspected causes to verify next for one effect.</a:t>
+            </a:r>
+          </a:p>
+          <a:p>
+            <a:pPr>
+              <a:defRPr sz="1100">
+                <a:solidFill>
+                  <a:srgbClr val="2D3741"/>
+                </a:solidFill>
+              </a:defRPr>
+            </a:pPr>
+            <a:r>
+              <a:t>Pattern to look for: testable causes, not the most opinions.</a:t>
+            </a:r>
+          </a:p>
+          <a:p>
+            <a:pPr>
+              <a:defRPr sz="1100">
+                <a:solidFill>
+                  <a:srgbClr val="2D3741"/>
+                </a:solidFill>
+              </a:defRPr>
+            </a:pPr>
+            <a:r>
+              <a:t>Good structure: one effect, branches, causes, markers, evidence.</a:t>
+            </a:r>
+          </a:p>
+          <a:p>
+            <a:pPr>
+              <a:defRPr sz="1100">
+                <a:solidFill>
+                  <a:srgbClr val="2D3741"/>
+                </a:solidFill>
+              </a:defRPr>
+            </a:pPr>
+            <a:r>
+              <a:t>Safe conclusion: suspected causes and verification priorities.</a:t>
             </a:r>
           </a:p>
         </p:txBody>
@@ -6109,55 +7638,55 @@
                   <a:srgbClr val="1B2733"/>
                 </a:solidFill>
               </a:rPr>
-              <a:t>Common mistakes</a:t>
-            </a:r>
-          </a:p>
-          <a:p>
-            <a:pPr>
-              <a:defRPr sz="1100">
-                <a:solidFill>
-                  <a:srgbClr val="2D3741"/>
-                </a:solidFill>
-              </a:defRPr>
-            </a:pPr>
-            <a:r>
-              <a:t>Mixing several effects on one diagram.</a:t>
-            </a:r>
-          </a:p>
-          <a:p>
-            <a:pPr>
-              <a:defRPr sz="1100">
-                <a:solidFill>
-                  <a:srgbClr val="2D3741"/>
-                </a:solidFill>
-              </a:defRPr>
-            </a:pPr>
-            <a:r>
-              <a:t>Listing symptoms as causes.</a:t>
-            </a:r>
-          </a:p>
-          <a:p>
-            <a:pPr>
-              <a:defRPr sz="1100">
-                <a:solidFill>
-                  <a:srgbClr val="2D3741"/>
-                </a:solidFill>
-              </a:defRPr>
-            </a:pPr>
-            <a:r>
-              <a:t>Marking causes verified without evidence.</a:t>
-            </a:r>
-          </a:p>
-          <a:p>
-            <a:pPr>
-              <a:defRPr sz="1100">
-                <a:solidFill>
-                  <a:srgbClr val="2D3741"/>
-                </a:solidFill>
-              </a:defRPr>
-            </a:pPr>
-            <a:r>
-              <a:t>Treating demo content as project evidence.</a:t>
+              <a:t>Overclaim to avoid</a:t>
+            </a:r>
+          </a:p>
+          <a:p>
+            <a:pPr>
+              <a:defRPr sz="1100">
+                <a:solidFill>
+                  <a:srgbClr val="2D3741"/>
+                </a:solidFill>
+              </a:defRPr>
+            </a:pPr>
+            <a:r>
+              <a:t>The diagram does not prove root cause.</a:t>
+            </a:r>
+          </a:p>
+          <a:p>
+            <a:pPr>
+              <a:defRPr sz="1100">
+                <a:solidFill>
+                  <a:srgbClr val="2D3741"/>
+                </a:solidFill>
+              </a:defRPr>
+            </a:pPr>
+            <a:r>
+              <a:t>The diagram does not prove countermeasure effectiveness.</a:t>
+            </a:r>
+          </a:p>
+          <a:p>
+            <a:pPr>
+              <a:defRPr sz="1100">
+                <a:solidFill>
+                  <a:srgbClr val="2D3741"/>
+                </a:solidFill>
+              </a:defRPr>
+            </a:pPr>
+            <a:r>
+              <a:t>Do not mix several effects on one fishbone.</a:t>
+            </a:r>
+          </a:p>
+          <a:p>
+            <a:pPr>
+              <a:defRPr sz="1100">
+                <a:solidFill>
+                  <a:srgbClr val="2D3741"/>
+                </a:solidFill>
+              </a:defRPr>
+            </a:pPr>
+            <a:r>
+              <a:t>Do not select causes without a verification method.</a:t>
             </a:r>
           </a:p>
         </p:txBody>
@@ -6241,7 +7770,7 @@
                   <a:srgbClr val="1B2733"/>
                 </a:solidFill>
               </a:rPr>
-              <a:t>Facilitator checklist and Python assist decision</a:t>
+              <a:t>Verification marker legend and cause wording guide</a:t>
             </a:r>
           </a:p>
         </p:txBody>
@@ -6370,55 +7899,55 @@
                   <a:srgbClr val="1B2733"/>
                 </a:solidFill>
               </a:rPr>
-              <a:t>Facilitator checklist</a:t>
-            </a:r>
-          </a:p>
-          <a:p>
-            <a:pPr>
-              <a:defRPr sz="1100">
-                <a:solidFill>
-                  <a:srgbClr val="2D3741"/>
-                </a:solidFill>
-              </a:defRPr>
-            </a:pPr>
-            <a:r>
-              <a:t>Effect statement matches project evidence.</a:t>
-            </a:r>
-          </a:p>
-          <a:p>
-            <a:pPr>
-              <a:defRPr sz="1100">
-                <a:solidFill>
-                  <a:srgbClr val="2D3741"/>
-                </a:solidFill>
-              </a:defRPr>
-            </a:pPr>
-            <a:r>
-              <a:t>Source and date range or session date shown.</a:t>
-            </a:r>
-          </a:p>
-          <a:p>
-            <a:pPr>
-              <a:defRPr sz="1100">
-                <a:solidFill>
-                  <a:srgbClr val="2D3741"/>
-                </a:solidFill>
-              </a:defRPr>
-            </a:pPr>
-            <a:r>
-              <a:t>Suspected and verified causes are separated.</a:t>
-            </a:r>
-          </a:p>
-          <a:p>
-            <a:pPr>
-              <a:defRPr sz="1100">
-                <a:solidFill>
-                  <a:srgbClr val="2D3741"/>
-                </a:solidFill>
-              </a:defRPr>
-            </a:pPr>
-            <a:r>
-              <a:t>Key conclusion and next action are written.</a:t>
+              <a:t>Verification marker legend</a:t>
+            </a:r>
+          </a:p>
+          <a:p>
+            <a:pPr>
+              <a:defRPr sz="1100">
+                <a:solidFill>
+                  <a:srgbClr val="2D3741"/>
+                </a:solidFill>
+              </a:defRPr>
+            </a:pPr>
+            <a:r>
+              <a:t>[S] Suspected: proposed but not selected.</a:t>
+            </a:r>
+          </a:p>
+          <a:p>
+            <a:pPr>
+              <a:defRPr sz="1100">
+                <a:solidFill>
+                  <a:srgbClr val="2D3741"/>
+                </a:solidFill>
+              </a:defRPr>
+            </a:pPr>
+            <a:r>
+              <a:t>[V?] Selected for verification: check next.</a:t>
+            </a:r>
+          </a:p>
+          <a:p>
+            <a:pPr>
+              <a:defRPr sz="1100">
+                <a:solidFill>
+                  <a:srgbClr val="2D3741"/>
+                </a:solidFill>
+              </a:defRPr>
+            </a:pPr>
+            <a:r>
+              <a:t>[V] Verified: supported by later evidence.</a:t>
+            </a:r>
+          </a:p>
+          <a:p>
+            <a:pPr>
+              <a:defRPr sz="1100">
+                <a:solidFill>
+                  <a:srgbClr val="2D3741"/>
+                </a:solidFill>
+              </a:defRPr>
+            </a:pPr>
+            <a:r>
+              <a:t>[X] Rejected: checked and not supported.</a:t>
             </a:r>
           </a:p>
         </p:txBody>
@@ -6471,55 +8000,55 @@
                   <a:srgbClr val="1B2733"/>
                 </a:solidFill>
               </a:rPr>
-              <a:t>Python assist decision</a:t>
-            </a:r>
-          </a:p>
-          <a:p>
-            <a:pPr>
-              <a:defRPr sz="1100">
-                <a:solidFill>
-                  <a:srgbClr val="2D3741"/>
-                </a:solidFill>
-              </a:defRPr>
-            </a:pPr>
-            <a:r>
-              <a:t>PowerPoint is enough for teaching, draft, and diagram editing.</a:t>
-            </a:r>
-          </a:p>
-          <a:p>
-            <a:pPr>
-              <a:defRPr sz="1100">
-                <a:solidFill>
-                  <a:srgbClr val="2D3741"/>
-                </a:solidFill>
-              </a:defRPr>
-            </a:pPr>
-            <a:r>
-              <a:t>Python is not normally needed for this visual method.</a:t>
-            </a:r>
-          </a:p>
-          <a:p>
-            <a:pPr>
-              <a:defRPr sz="1100">
-                <a:solidFill>
-                  <a:srgbClr val="2D3741"/>
-                </a:solidFill>
-              </a:defRPr>
-            </a:pPr>
-            <a:r>
-              <a:t>Use Python later only to summarize verification data.</a:t>
-            </a:r>
-          </a:p>
-          <a:p>
-            <a:pPr>
-              <a:defRPr sz="1100">
-                <a:solidFill>
-                  <a:srgbClr val="2D3741"/>
-                </a:solidFill>
-              </a:defRPr>
-            </a:pPr>
-            <a:r>
-              <a:t>High-rigor data claims need a validated path.</a:t>
+              <a:t>Cause wording guide</a:t>
+            </a:r>
+          </a:p>
+          <a:p>
+            <a:pPr>
+              <a:defRPr sz="1100">
+                <a:solidFill>
+                  <a:srgbClr val="2D3741"/>
+                </a:solidFill>
+              </a:defRPr>
+            </a:pPr>
+            <a:r>
+              <a:t>Weak wording: "Operator error".</a:t>
+            </a:r>
+          </a:p>
+          <a:p>
+            <a:pPr>
+              <a:defRPr sz="1100">
+                <a:solidFill>
+                  <a:srgbClr val="2D3741"/>
+                </a:solidFill>
+              </a:defRPr>
+            </a:pPr>
+            <a:r>
+              <a:t>Testable wording: "New operators lack label-check training".</a:t>
+            </a:r>
+          </a:p>
+          <a:p>
+            <a:pPr>
+              <a:defRPr sz="1100">
+                <a:solidFill>
+                  <a:srgbClr val="2D3741"/>
+                </a:solidFill>
+              </a:defRPr>
+            </a:pPr>
+            <a:r>
+              <a:t>Weak wording: "Bad machine".</a:t>
+            </a:r>
+          </a:p>
+          <a:p>
+            <a:pPr>
+              <a:defRPr sz="1100">
+                <a:solidFill>
+                  <a:srgbClr val="2D3741"/>
+                </a:solidFill>
+              </a:defRPr>
+            </a:pPr>
+            <a:r>
+              <a:t>Testable wording: "Scanner warning is not visible".</a:t>
             </a:r>
           </a:p>
         </p:txBody>
@@ -6603,7 +8132,7 @@
                   <a:srgbClr val="1B2733"/>
                 </a:solidFill>
               </a:rPr>
-              <a:t>Evidence/source note</a:t>
+              <a:t>Editable fishbone diagram</a:t>
             </a:r>
           </a:p>
         </p:txBody>
@@ -6692,10 +8221,174 @@
         </p:nvSpPr>
         <p:spPr>
           <a:xfrm>
-            <a:off x="640080" y="1325880"/>
-            <a:ext cx="5212080" cy="4526280"/>
+            <a:off x="640080" y="1051560"/>
+            <a:ext cx="4937760" cy="329184"/>
           </a:xfrm>
           <a:prstGeom prst="roundRect">
+            <a:avLst/>
+          </a:prstGeom>
+          <a:solidFill>
+            <a:srgbClr val="FFF2CC"/>
+          </a:solidFill>
+          <a:ln>
+            <a:solidFill>
+              <a:srgbClr val="D69F2E"/>
+            </a:solidFill>
+          </a:ln>
+        </p:spPr>
+        <p:style>
+          <a:lnRef idx="1">
+            <a:schemeClr val="accent1"/>
+          </a:lnRef>
+          <a:fillRef idx="3">
+            <a:schemeClr val="accent1"/>
+          </a:fillRef>
+          <a:effectRef idx="2">
+            <a:schemeClr val="accent1"/>
+          </a:effectRef>
+          <a:fontRef idx="minor">
+            <a:schemeClr val="lt1"/>
+          </a:fontRef>
+        </p:style>
+        <p:txBody>
+          <a:bodyPr rtlCol="0" anchor="ctr"/>
+          <a:lstStyle/>
+          <a:p>
+            <a:pPr algn="ctr"/>
+            <a:r>
+              <a:rPr b="1" sz="1100">
+                <a:solidFill>
+                  <a:srgbClr val="664B11"/>
+                </a:solidFill>
+              </a:rPr>
+              <a:t>Replace demo causes with project evidence</a:t>
+            </a:r>
+          </a:p>
+        </p:txBody>
+      </p:sp>
+      <p:sp>
+        <p:nvSpPr>
+          <p:cNvPr id="6" name="TextBox 5"/>
+          <p:cNvSpPr txBox="1"/>
+          <p:nvPr/>
+        </p:nvSpPr>
+        <p:spPr>
+          <a:xfrm>
+            <a:off x="8641080" y="2468880"/>
+            <a:ext cx="2514600" cy="685800"/>
+          </a:xfrm>
+          <a:prstGeom prst="rect">
+            <a:avLst/>
+          </a:prstGeom>
+          <a:solidFill>
+            <a:srgbClr val="EEF4F3"/>
+          </a:solidFill>
+          <a:ln>
+            <a:solidFill>
+              <a:srgbClr val="427E78"/>
+            </a:solidFill>
+          </a:ln>
+        </p:spPr>
+        <p:txBody>
+          <a:bodyPr wrap="square" lIns="73152" rIns="73152">
+            <a:spAutoFit/>
+          </a:bodyPr>
+          <a:lstStyle/>
+          <a:p>
+            <a:r>
+              <a:rPr sz="1300" b="1">
+                <a:solidFill>
+                  <a:srgbClr val="1B2733"/>
+                </a:solidFill>
+              </a:rPr>
+              <a:t>Effect statement
+{{effect_statement}}</a:t>
+            </a:r>
+          </a:p>
+        </p:txBody>
+      </p:sp>
+      <p:cxnSp>
+        <p:nvCxnSpPr>
+          <p:cNvPr id="7" name="Connector 6"/>
+          <p:cNvCxnSpPr/>
+          <p:nvPr/>
+        </p:nvCxnSpPr>
+        <p:spPr>
+          <a:xfrm>
+            <a:off x="960120" y="2816352"/>
+            <a:ext cx="7680960" cy="0"/>
+          </a:xfrm>
+          <a:prstGeom prst="line">
+            <a:avLst/>
+          </a:prstGeom>
+          <a:ln w="28575">
+            <a:solidFill>
+              <a:srgbClr val="427E78"/>
+            </a:solidFill>
+          </a:ln>
+        </p:spPr>
+        <p:style>
+          <a:lnRef idx="2">
+            <a:schemeClr val="accent1"/>
+          </a:lnRef>
+          <a:fillRef idx="0">
+            <a:schemeClr val="accent1"/>
+          </a:fillRef>
+          <a:effectRef idx="1">
+            <a:schemeClr val="accent1"/>
+          </a:effectRef>
+          <a:fontRef idx="minor">
+            <a:schemeClr val="tx1"/>
+          </a:fontRef>
+        </p:style>
+      </p:cxnSp>
+      <p:cxnSp>
+        <p:nvCxnSpPr>
+          <p:cNvPr id="8" name="Connector 7"/>
+          <p:cNvCxnSpPr/>
+          <p:nvPr/>
+        </p:nvCxnSpPr>
+        <p:spPr>
+          <a:xfrm flipV="1">
+            <a:off x="1143000" y="1234440"/>
+            <a:ext cx="1371600" cy="1581912"/>
+          </a:xfrm>
+          <a:prstGeom prst="line">
+            <a:avLst/>
+          </a:prstGeom>
+          <a:ln w="19050">
+            <a:solidFill>
+              <a:srgbClr val="788986"/>
+            </a:solidFill>
+          </a:ln>
+        </p:spPr>
+        <p:style>
+          <a:lnRef idx="2">
+            <a:schemeClr val="accent1"/>
+          </a:lnRef>
+          <a:fillRef idx="0">
+            <a:schemeClr val="accent1"/>
+          </a:fillRef>
+          <a:effectRef idx="1">
+            <a:schemeClr val="accent1"/>
+          </a:effectRef>
+          <a:fontRef idx="minor">
+            <a:schemeClr val="tx1"/>
+          </a:fontRef>
+        </p:style>
+      </p:cxnSp>
+      <p:sp>
+        <p:nvSpPr>
+          <p:cNvPr id="9" name="TextBox 8"/>
+          <p:cNvSpPr txBox="1"/>
+          <p:nvPr/>
+        </p:nvSpPr>
+        <p:spPr>
+          <a:xfrm>
+            <a:off x="1947672" y="612648"/>
+            <a:ext cx="1874519" cy="658368"/>
+          </a:xfrm>
+          <a:prstGeom prst="rect">
             <a:avLst/>
           </a:prstGeom>
           <a:solidFill>
@@ -6707,96 +8400,71 @@
             </a:solidFill>
           </a:ln>
         </p:spPr>
+        <p:txBody>
+          <a:bodyPr wrap="square" lIns="73152" rIns="73152">
+            <a:spAutoFit/>
+          </a:bodyPr>
+          <a:lstStyle/>
+          <a:p>
+            <a:r>
+              <a:rPr sz="900" b="0">
+                <a:solidFill>
+                  <a:srgbClr val="232D37"/>
+                </a:solidFill>
+              </a:rPr>
+              <a:t>Method
+S: Label check after boxing</a:t>
+            </a:r>
+          </a:p>
+        </p:txBody>
+      </p:sp>
+      <p:cxnSp>
+        <p:nvCxnSpPr>
+          <p:cNvPr id="10" name="Connector 9"/>
+          <p:cNvCxnSpPr/>
+          <p:nvPr/>
+        </p:nvCxnSpPr>
+        <p:spPr>
+          <a:xfrm flipV="1">
+            <a:off x="3246120" y="1234440"/>
+            <a:ext cx="1234440" cy="1581912"/>
+          </a:xfrm>
+          <a:prstGeom prst="line">
+            <a:avLst/>
+          </a:prstGeom>
+          <a:ln w="19050">
+            <a:solidFill>
+              <a:srgbClr val="788986"/>
+            </a:solidFill>
+          </a:ln>
+        </p:spPr>
         <p:style>
-          <a:lnRef idx="1">
+          <a:lnRef idx="2">
             <a:schemeClr val="accent1"/>
           </a:lnRef>
-          <a:fillRef idx="3">
+          <a:fillRef idx="0">
             <a:schemeClr val="accent1"/>
           </a:fillRef>
-          <a:effectRef idx="2">
+          <a:effectRef idx="1">
             <a:schemeClr val="accent1"/>
           </a:effectRef>
           <a:fontRef idx="minor">
-            <a:schemeClr val="lt1"/>
+            <a:schemeClr val="tx1"/>
           </a:fontRef>
         </p:style>
-        <p:txBody>
-          <a:bodyPr rtlCol="0" anchor="t" lIns="164592" rIns="164592" tIns="128016"/>
-          <a:lstStyle/>
-          <a:p>
-            <a:pPr algn="ctr"/>
-            <a:r>
-              <a:rPr b="1" sz="1500">
-                <a:solidFill>
-                  <a:srgbClr val="1B2733"/>
-                </a:solidFill>
-              </a:rPr>
-              <a:t>Evidence levels</a:t>
-            </a:r>
-          </a:p>
-          <a:p>
-            <a:pPr>
-              <a:defRPr sz="1100">
-                <a:solidFill>
-                  <a:srgbClr val="2D3741"/>
-                </a:solidFill>
-              </a:defRPr>
-            </a:pPr>
-            <a:r>
-              <a:t>Level 1: teaching/draft PowerPoint edits.</a:t>
-            </a:r>
-          </a:p>
-          <a:p>
-            <a:pPr>
-              <a:defRPr sz="1100">
-                <a:solidFill>
-                  <a:srgbClr val="2D3741"/>
-                </a:solidFill>
-              </a:defRPr>
-            </a:pPr>
-            <a:r>
-              <a:t>Level 2: normal project with source and checklist evidence.</a:t>
-            </a:r>
-          </a:p>
-          <a:p>
-            <a:pPr>
-              <a:defRPr sz="1100">
-                <a:solidFill>
-                  <a:srgbClr val="2D3741"/>
-                </a:solidFill>
-              </a:defRPr>
-            </a:pPr>
-            <a:r>
-              <a:t>Level 3: formal review with source data and versioned template.</a:t>
-            </a:r>
-          </a:p>
-          <a:p>
-            <a:pPr>
-              <a:defRPr sz="1100">
-                <a:solidFill>
-                  <a:srgbClr val="2D3741"/>
-                </a:solidFill>
-              </a:defRPr>
-            </a:pPr>
-            <a:r>
-              <a:t>Level 4: audit/high-risk reproducible evidence.</a:t>
-            </a:r>
-          </a:p>
-        </p:txBody>
-      </p:sp>
-      <p:sp>
-        <p:nvSpPr>
-          <p:cNvPr id="6" name="Rounded Rectangle 5"/>
-          <p:cNvSpPr/>
-          <p:nvPr/>
-        </p:nvSpPr>
-        <p:spPr>
-          <a:xfrm>
-            <a:off x="6263640" y="1325880"/>
-            <a:ext cx="5212080" cy="4526280"/>
-          </a:xfrm>
-          <a:prstGeom prst="roundRect">
+      </p:cxnSp>
+      <p:sp>
+        <p:nvSpPr>
+          <p:cNvPr id="11" name="TextBox 10"/>
+          <p:cNvSpPr txBox="1"/>
+          <p:nvPr/>
+        </p:nvSpPr>
+        <p:spPr>
+          <a:xfrm>
+            <a:off x="3913632" y="612648"/>
+            <a:ext cx="1874519" cy="658368"/>
+          </a:xfrm>
+          <a:prstGeom prst="rect">
             <a:avLst/>
           </a:prstGeom>
           <a:solidFill>
@@ -6808,6 +8476,351 @@
             </a:solidFill>
           </a:ln>
         </p:spPr>
+        <p:txBody>
+          <a:bodyPr wrap="square" lIns="73152" rIns="73152">
+            <a:spAutoFit/>
+          </a:bodyPr>
+          <a:lstStyle/>
+          <a:p>
+            <a:r>
+              <a:rPr sz="900" b="0">
+                <a:solidFill>
+                  <a:srgbClr val="232D37"/>
+                </a:solidFill>
+              </a:rPr>
+              <a:t>Machine
+V?: Scanner warning easy to miss</a:t>
+            </a:r>
+          </a:p>
+        </p:txBody>
+      </p:sp>
+      <p:cxnSp>
+        <p:nvCxnSpPr>
+          <p:cNvPr id="12" name="Connector 11"/>
+          <p:cNvCxnSpPr/>
+          <p:nvPr/>
+        </p:nvCxnSpPr>
+        <p:spPr>
+          <a:xfrm flipV="1">
+            <a:off x="5257800" y="1234440"/>
+            <a:ext cx="1234440" cy="1581912"/>
+          </a:xfrm>
+          <a:prstGeom prst="line">
+            <a:avLst/>
+          </a:prstGeom>
+          <a:ln w="19050">
+            <a:solidFill>
+              <a:srgbClr val="788986"/>
+            </a:solidFill>
+          </a:ln>
+        </p:spPr>
+        <p:style>
+          <a:lnRef idx="2">
+            <a:schemeClr val="accent1"/>
+          </a:lnRef>
+          <a:fillRef idx="0">
+            <a:schemeClr val="accent1"/>
+          </a:fillRef>
+          <a:effectRef idx="1">
+            <a:schemeClr val="accent1"/>
+          </a:effectRef>
+          <a:fontRef idx="minor">
+            <a:schemeClr val="tx1"/>
+          </a:fontRef>
+        </p:style>
+      </p:cxnSp>
+      <p:sp>
+        <p:nvSpPr>
+          <p:cNvPr id="13" name="TextBox 12"/>
+          <p:cNvSpPr txBox="1"/>
+          <p:nvPr/>
+        </p:nvSpPr>
+        <p:spPr>
+          <a:xfrm>
+            <a:off x="5925312" y="612648"/>
+            <a:ext cx="1874519" cy="658368"/>
+          </a:xfrm>
+          <a:prstGeom prst="rect">
+            <a:avLst/>
+          </a:prstGeom>
+          <a:solidFill>
+            <a:srgbClr val="F8F9F7"/>
+          </a:solidFill>
+          <a:ln>
+            <a:solidFill>
+              <a:srgbClr val="BEC4BF"/>
+            </a:solidFill>
+          </a:ln>
+        </p:spPr>
+        <p:txBody>
+          <a:bodyPr wrap="square" lIns="73152" rIns="73152">
+            <a:spAutoFit/>
+          </a:bodyPr>
+          <a:lstStyle/>
+          <a:p>
+            <a:r>
+              <a:rPr sz="900" b="0">
+                <a:solidFill>
+                  <a:srgbClr val="232D37"/>
+                </a:solidFill>
+              </a:rPr>
+              <a:t>Material
+S: Similar label roll colors</a:t>
+            </a:r>
+          </a:p>
+        </p:txBody>
+      </p:sp>
+      <p:cxnSp>
+        <p:nvCxnSpPr>
+          <p:cNvPr id="14" name="Connector 13"/>
+          <p:cNvCxnSpPr/>
+          <p:nvPr/>
+        </p:nvCxnSpPr>
+        <p:spPr>
+          <a:xfrm>
+            <a:off x="1234440" y="2816352"/>
+            <a:ext cx="1371600" cy="1344168"/>
+          </a:xfrm>
+          <a:prstGeom prst="line">
+            <a:avLst/>
+          </a:prstGeom>
+          <a:ln w="19050">
+            <a:solidFill>
+              <a:srgbClr val="788986"/>
+            </a:solidFill>
+          </a:ln>
+        </p:spPr>
+        <p:style>
+          <a:lnRef idx="2">
+            <a:schemeClr val="accent1"/>
+          </a:lnRef>
+          <a:fillRef idx="0">
+            <a:schemeClr val="accent1"/>
+          </a:fillRef>
+          <a:effectRef idx="1">
+            <a:schemeClr val="accent1"/>
+          </a:effectRef>
+          <a:fontRef idx="minor">
+            <a:schemeClr val="tx1"/>
+          </a:fontRef>
+        </p:style>
+      </p:cxnSp>
+      <p:sp>
+        <p:nvSpPr>
+          <p:cNvPr id="15" name="TextBox 14"/>
+          <p:cNvSpPr txBox="1"/>
+          <p:nvPr/>
+        </p:nvSpPr>
+        <p:spPr>
+          <a:xfrm>
+            <a:off x="2039112" y="4251959"/>
+            <a:ext cx="1874519" cy="658368"/>
+          </a:xfrm>
+          <a:prstGeom prst="rect">
+            <a:avLst/>
+          </a:prstGeom>
+          <a:solidFill>
+            <a:srgbClr val="F8F9F7"/>
+          </a:solidFill>
+          <a:ln>
+            <a:solidFill>
+              <a:srgbClr val="BEC4BF"/>
+            </a:solidFill>
+          </a:ln>
+        </p:spPr>
+        <p:txBody>
+          <a:bodyPr wrap="square" lIns="73152" rIns="73152">
+            <a:spAutoFit/>
+          </a:bodyPr>
+          <a:lstStyle/>
+          <a:p>
+            <a:r>
+              <a:rPr sz="900" b="0">
+                <a:solidFill>
+                  <a:srgbClr val="232D37"/>
+                </a:solidFill>
+              </a:rPr>
+              <a:t>People
+S: New operators rotate in</a:t>
+            </a:r>
+          </a:p>
+        </p:txBody>
+      </p:sp>
+      <p:cxnSp>
+        <p:nvCxnSpPr>
+          <p:cNvPr id="16" name="Connector 15"/>
+          <p:cNvCxnSpPr/>
+          <p:nvPr/>
+        </p:nvCxnSpPr>
+        <p:spPr>
+          <a:xfrm>
+            <a:off x="3429000" y="2816352"/>
+            <a:ext cx="1371600" cy="1344168"/>
+          </a:xfrm>
+          <a:prstGeom prst="line">
+            <a:avLst/>
+          </a:prstGeom>
+          <a:ln w="19050">
+            <a:solidFill>
+              <a:srgbClr val="788986"/>
+            </a:solidFill>
+          </a:ln>
+        </p:spPr>
+        <p:style>
+          <a:lnRef idx="2">
+            <a:schemeClr val="accent1"/>
+          </a:lnRef>
+          <a:fillRef idx="0">
+            <a:schemeClr val="accent1"/>
+          </a:fillRef>
+          <a:effectRef idx="1">
+            <a:schemeClr val="accent1"/>
+          </a:effectRef>
+          <a:fontRef idx="minor">
+            <a:schemeClr val="tx1"/>
+          </a:fontRef>
+        </p:style>
+      </p:cxnSp>
+      <p:sp>
+        <p:nvSpPr>
+          <p:cNvPr id="17" name="TextBox 16"/>
+          <p:cNvSpPr txBox="1"/>
+          <p:nvPr/>
+        </p:nvSpPr>
+        <p:spPr>
+          <a:xfrm>
+            <a:off x="4233672" y="4251959"/>
+            <a:ext cx="1874519" cy="658368"/>
+          </a:xfrm>
+          <a:prstGeom prst="rect">
+            <a:avLst/>
+          </a:prstGeom>
+          <a:solidFill>
+            <a:srgbClr val="F8F9F7"/>
+          </a:solidFill>
+          <a:ln>
+            <a:solidFill>
+              <a:srgbClr val="BEC4BF"/>
+            </a:solidFill>
+          </a:ln>
+        </p:spPr>
+        <p:txBody>
+          <a:bodyPr wrap="square" lIns="73152" rIns="73152">
+            <a:spAutoFit/>
+          </a:bodyPr>
+          <a:lstStyle/>
+          <a:p>
+            <a:r>
+              <a:rPr sz="900" b="0">
+                <a:solidFill>
+                  <a:srgbClr val="232D37"/>
+                </a:solidFill>
+              </a:rPr>
+              <a:t>Environment
+V?: Mixed SKU paperwork</a:t>
+            </a:r>
+          </a:p>
+        </p:txBody>
+      </p:sp>
+      <p:cxnSp>
+        <p:nvCxnSpPr>
+          <p:cNvPr id="18" name="Connector 17"/>
+          <p:cNvCxnSpPr/>
+          <p:nvPr/>
+        </p:nvCxnSpPr>
+        <p:spPr>
+          <a:xfrm>
+            <a:off x="5532120" y="2816352"/>
+            <a:ext cx="1371600" cy="1344168"/>
+          </a:xfrm>
+          <a:prstGeom prst="line">
+            <a:avLst/>
+          </a:prstGeom>
+          <a:ln w="19050">
+            <a:solidFill>
+              <a:srgbClr val="788986"/>
+            </a:solidFill>
+          </a:ln>
+        </p:spPr>
+        <p:style>
+          <a:lnRef idx="2">
+            <a:schemeClr val="accent1"/>
+          </a:lnRef>
+          <a:fillRef idx="0">
+            <a:schemeClr val="accent1"/>
+          </a:fillRef>
+          <a:effectRef idx="1">
+            <a:schemeClr val="accent1"/>
+          </a:effectRef>
+          <a:fontRef idx="minor">
+            <a:schemeClr val="tx1"/>
+          </a:fontRef>
+        </p:style>
+      </p:cxnSp>
+      <p:sp>
+        <p:nvSpPr>
+          <p:cNvPr id="19" name="TextBox 18"/>
+          <p:cNvSpPr txBox="1"/>
+          <p:nvPr/>
+        </p:nvSpPr>
+        <p:spPr>
+          <a:xfrm>
+            <a:off x="6336792" y="4251959"/>
+            <a:ext cx="1874519" cy="658368"/>
+          </a:xfrm>
+          <a:prstGeom prst="rect">
+            <a:avLst/>
+          </a:prstGeom>
+          <a:solidFill>
+            <a:srgbClr val="F8F9F7"/>
+          </a:solidFill>
+          <a:ln>
+            <a:solidFill>
+              <a:srgbClr val="BEC4BF"/>
+            </a:solidFill>
+          </a:ln>
+        </p:spPr>
+        <p:txBody>
+          <a:bodyPr wrap="square" lIns="73152" rIns="73152">
+            <a:spAutoFit/>
+          </a:bodyPr>
+          <a:lstStyle/>
+          <a:p>
+            <a:r>
+              <a:rPr sz="900" b="0">
+                <a:solidFill>
+                  <a:srgbClr val="232D37"/>
+                </a:solidFill>
+              </a:rPr>
+              <a:t>Measurement
+X: Audit form not root cause</a:t>
+            </a:r>
+          </a:p>
+        </p:txBody>
+      </p:sp>
+      <p:sp>
+        <p:nvSpPr>
+          <p:cNvPr id="20" name="Rounded Rectangle 19"/>
+          <p:cNvSpPr/>
+          <p:nvPr/>
+        </p:nvSpPr>
+        <p:spPr>
+          <a:xfrm>
+            <a:off x="640080" y="5349240"/>
+            <a:ext cx="3657600" cy="777240"/>
+          </a:xfrm>
+          <a:prstGeom prst="roundRect">
+            <a:avLst/>
+          </a:prstGeom>
+          <a:solidFill>
+            <a:srgbClr val="F8F9F7"/>
+          </a:solidFill>
+          <a:ln>
+            <a:solidFill>
+              <a:srgbClr val="BEC4BF"/>
+            </a:solidFill>
+          </a:ln>
+        </p:spPr>
         <p:style>
           <a:lnRef idx="1">
             <a:schemeClr val="accent1"/>
@@ -6833,62 +8846,180 @@
                   <a:srgbClr val="1B2733"/>
                 </a:solidFill>
               </a:rPr>
-              <a:t>Evidence/source note</a:t>
-            </a:r>
-          </a:p>
-          <a:p>
-            <a:pPr>
-              <a:defRPr sz="1100">
-                <a:solidFill>
-                  <a:srgbClr val="2D3741"/>
-                </a:solidFill>
-              </a:defRPr>
-            </a:pPr>
-            <a:r>
-              <a:t>Record source.</a:t>
-            </a:r>
-          </a:p>
-          <a:p>
-            <a:pPr>
-              <a:defRPr sz="1100">
-                <a:solidFill>
-                  <a:srgbClr val="2D3741"/>
-                </a:solidFill>
-              </a:defRPr>
-            </a:pPr>
-            <a:r>
-              <a:t>Record date range or session date.</a:t>
-            </a:r>
-          </a:p>
-          <a:p>
-            <a:pPr>
-              <a:defRPr sz="1100">
-                <a:solidFill>
-                  <a:srgbClr val="2D3741"/>
-                </a:solidFill>
-              </a:defRPr>
-            </a:pPr>
-            <a:r>
-              <a:t>Record assumptions and verification status.</a:t>
-            </a:r>
-          </a:p>
-          <a:p>
-            <a:pPr>
-              <a:defRPr sz="1100">
-                <a:solidFill>
-                  <a:srgbClr val="2D3741"/>
-                </a:solidFill>
-              </a:defRPr>
-            </a:pPr>
-            <a:r>
-              <a:t>Record prepared by/date.</a:t>
-            </a:r>
-          </a:p>
-        </p:txBody>
-      </p:sp>
-      <p:sp>
-        <p:nvSpPr>
-          <p:cNvPr id="7" name="TextBox 6"/>
+              <a:t>Verification marker legend</a:t>
+            </a:r>
+          </a:p>
+          <a:p>
+            <a:pPr>
+              <a:defRPr sz="1100">
+                <a:solidFill>
+                  <a:srgbClr val="2D3741"/>
+                </a:solidFill>
+              </a:defRPr>
+            </a:pPr>
+            <a:r>
+              <a:t>[S] Suspected | [V?] Selected for verification | [V] Verified | [X] Rejected</a:t>
+            </a:r>
+          </a:p>
+        </p:txBody>
+      </p:sp>
+      <p:sp>
+        <p:nvSpPr>
+          <p:cNvPr id="21" name="Rounded Rectangle 20"/>
+          <p:cNvSpPr/>
+          <p:nvPr/>
+        </p:nvSpPr>
+        <p:spPr>
+          <a:xfrm>
+            <a:off x="4526280" y="5349240"/>
+            <a:ext cx="3246120" cy="777240"/>
+          </a:xfrm>
+          <a:prstGeom prst="roundRect">
+            <a:avLst/>
+          </a:prstGeom>
+          <a:solidFill>
+            <a:srgbClr val="F8F9F7"/>
+          </a:solidFill>
+          <a:ln>
+            <a:solidFill>
+              <a:srgbClr val="BEC4BF"/>
+            </a:solidFill>
+          </a:ln>
+        </p:spPr>
+        <p:style>
+          <a:lnRef idx="1">
+            <a:schemeClr val="accent1"/>
+          </a:lnRef>
+          <a:fillRef idx="3">
+            <a:schemeClr val="accent1"/>
+          </a:fillRef>
+          <a:effectRef idx="2">
+            <a:schemeClr val="accent1"/>
+          </a:effectRef>
+          <a:fontRef idx="minor">
+            <a:schemeClr val="lt1"/>
+          </a:fontRef>
+        </p:style>
+        <p:txBody>
+          <a:bodyPr rtlCol="0" anchor="t" lIns="164592" rIns="164592" tIns="128016"/>
+          <a:lstStyle/>
+          <a:p>
+            <a:pPr algn="ctr"/>
+            <a:r>
+              <a:rPr b="1" sz="1500">
+                <a:solidFill>
+                  <a:srgbClr val="1B2733"/>
+                </a:solidFill>
+              </a:rPr>
+              <a:t>Selected causes to verify</a:t>
+            </a:r>
+          </a:p>
+          <a:p>
+            <a:pPr>
+              <a:defRPr sz="1100">
+                <a:solidFill>
+                  <a:srgbClr val="2D3741"/>
+                </a:solidFill>
+              </a:defRPr>
+            </a:pPr>
+            <a:r>
+              <a:t>Choose 2-3 causes with clear verification methods.</a:t>
+            </a:r>
+          </a:p>
+        </p:txBody>
+      </p:sp>
+      <p:sp>
+        <p:nvSpPr>
+          <p:cNvPr id="22" name="Rounded Rectangle 21"/>
+          <p:cNvSpPr/>
+          <p:nvPr/>
+        </p:nvSpPr>
+        <p:spPr>
+          <a:xfrm>
+            <a:off x="8001000" y="4160520"/>
+            <a:ext cx="3337560" cy="1508760"/>
+          </a:xfrm>
+          <a:prstGeom prst="roundRect">
+            <a:avLst/>
+          </a:prstGeom>
+          <a:solidFill>
+            <a:srgbClr val="F8F9F7"/>
+          </a:solidFill>
+          <a:ln>
+            <a:solidFill>
+              <a:srgbClr val="BEC4BF"/>
+            </a:solidFill>
+          </a:ln>
+        </p:spPr>
+        <p:style>
+          <a:lnRef idx="1">
+            <a:schemeClr val="accent1"/>
+          </a:lnRef>
+          <a:fillRef idx="3">
+            <a:schemeClr val="accent1"/>
+          </a:fillRef>
+          <a:effectRef idx="2">
+            <a:schemeClr val="accent1"/>
+          </a:effectRef>
+          <a:fontRef idx="minor">
+            <a:schemeClr val="lt1"/>
+          </a:fontRef>
+        </p:style>
+        <p:txBody>
+          <a:bodyPr rtlCol="0" anchor="t" lIns="164592" rIns="164592" tIns="128016"/>
+          <a:lstStyle/>
+          <a:p>
+            <a:pPr algn="ctr"/>
+            <a:r>
+              <a:rPr b="1" sz="1500">
+                <a:solidFill>
+                  <a:srgbClr val="1B2733"/>
+                </a:solidFill>
+              </a:rPr>
+              <a:t>Evidence/source fields</a:t>
+            </a:r>
+          </a:p>
+          <a:p>
+            <a:pPr>
+              <a:defRPr sz="1100">
+                <a:solidFill>
+                  <a:srgbClr val="2D3741"/>
+                </a:solidFill>
+              </a:defRPr>
+            </a:pPr>
+            <a:r>
+              <a:t>Source: [team session, gemba, records].</a:t>
+            </a:r>
+          </a:p>
+          <a:p>
+            <a:pPr>
+              <a:defRPr sz="1100">
+                <a:solidFill>
+                  <a:srgbClr val="2D3741"/>
+                </a:solidFill>
+              </a:defRPr>
+            </a:pPr>
+            <a:r>
+              <a:t>Date range/session date: [date].</a:t>
+            </a:r>
+          </a:p>
+          <a:p>
+            <a:pPr>
+              <a:defRPr sz="1100">
+                <a:solidFill>
+                  <a:srgbClr val="2D3741"/>
+                </a:solidFill>
+              </a:defRPr>
+            </a:pPr>
+            <a:r>
+              <a:t>Prepared by/date: [name/date].</a:t>
+            </a:r>
+          </a:p>
+        </p:txBody>
+      </p:sp>
+      <p:sp>
+        <p:nvSpPr>
+          <p:cNvPr id="23" name="TextBox 22"/>
           <p:cNvSpPr txBox="1"/>
           <p:nvPr/>
         </p:nvSpPr>
@@ -6965,7 +9096,7 @@
                   <a:srgbClr val="1B2733"/>
                 </a:solidFill>
               </a:rPr>
-              <a:t>DEMO EXAMPLE - not project evidence</a:t>
+              <a:t>Cause verification plan</a:t>
             </a:r>
           </a:p>
         </p:txBody>
@@ -7046,59 +9177,503 @@
           </a:p>
         </p:txBody>
       </p:sp>
-      <p:sp>
-        <p:nvSpPr>
-          <p:cNvPr id="5" name="Rounded Rectangle 4"/>
-          <p:cNvSpPr/>
-          <p:nvPr/>
-        </p:nvSpPr>
-        <p:spPr>
-          <a:xfrm>
-            <a:off x="640080" y="1051560"/>
-            <a:ext cx="3840480" cy="329184"/>
-          </a:xfrm>
-          <a:prstGeom prst="roundRect">
-            <a:avLst/>
-          </a:prstGeom>
-          <a:solidFill>
-            <a:srgbClr val="FFF2CC"/>
-          </a:solidFill>
-          <a:ln>
-            <a:solidFill>
-              <a:srgbClr val="D69F2E"/>
-            </a:solidFill>
-          </a:ln>
-        </p:spPr>
-        <p:style>
-          <a:lnRef idx="1">
-            <a:schemeClr val="accent1"/>
-          </a:lnRef>
-          <a:fillRef idx="3">
-            <a:schemeClr val="accent1"/>
-          </a:fillRef>
-          <a:effectRef idx="2">
-            <a:schemeClr val="accent1"/>
-          </a:effectRef>
-          <a:fontRef idx="minor">
-            <a:schemeClr val="lt1"/>
-          </a:fontRef>
-        </p:style>
-        <p:txBody>
-          <a:bodyPr rtlCol="0" anchor="ctr"/>
-          <a:lstStyle/>
-          <a:p>
-            <a:pPr algn="ctr"/>
-            <a:r>
-              <a:rPr b="1" sz="1100">
-                <a:solidFill>
-                  <a:srgbClr val="664B11"/>
-                </a:solidFill>
-              </a:rPr>
-              <a:t>DEMO EXAMPLE - not project evidence</a:t>
-            </a:r>
-          </a:p>
-        </p:txBody>
-      </p:sp>
+      <p:graphicFrame>
+        <p:nvGraphicFramePr>
+          <p:cNvPr id="5" name="Table 4"/>
+          <p:cNvGraphicFramePr>
+            <a:graphicFrameLocks noGrp="1"/>
+          </p:cNvGraphicFramePr>
+          <p:nvPr/>
+        </p:nvGraphicFramePr>
+        <p:xfrm>
+          <a:off x="685800" y="1417320"/>
+          <a:ext cx="10835640" cy="2011680"/>
+        </p:xfrm>
+        <a:graphic>
+          <a:graphicData uri="http://schemas.openxmlformats.org/drawingml/2006/table">
+            <a:tbl>
+              <a:tblPr firstRow="1" bandRow="1">
+                <a:tableStyleId>{5C22544A-7EE6-4342-B048-85BDC9FD1C3A}</a:tableStyleId>
+              </a:tblPr>
+              <a:tblGrid>
+                <a:gridCol w="2167128"/>
+                <a:gridCol w="2167128"/>
+                <a:gridCol w="2167128"/>
+                <a:gridCol w="2167128"/>
+                <a:gridCol w="2167128"/>
+              </a:tblGrid>
+              <a:tr h="502920">
+                <a:tc>
+                  <a:txBody>
+                    <a:bodyPr/>
+                    <a:lstStyle/>
+                    <a:p>
+                      <a:pPr>
+                        <a:defRPr sz="800">
+                          <a:solidFill>
+                            <a:srgbClr val="FFFFFF"/>
+                          </a:solidFill>
+                        </a:defRPr>
+                      </a:pPr>
+                      <a:r>
+                        <a:t>Selected cause</a:t>
+                      </a:r>
+                    </a:p>
+                  </a:txBody>
+                  <a:tcPr marL="45720" marR="45720" marT="27432" marB="27432">
+                    <a:solidFill>
+                      <a:srgbClr val="427E78"/>
+                    </a:solidFill>
+                  </a:tcPr>
+                </a:tc>
+                <a:tc>
+                  <a:txBody>
+                    <a:bodyPr/>
+                    <a:lstStyle/>
+                    <a:p>
+                      <a:pPr>
+                        <a:defRPr sz="800">
+                          <a:solidFill>
+                            <a:srgbClr val="FFFFFF"/>
+                          </a:solidFill>
+                        </a:defRPr>
+                      </a:pPr>
+                      <a:r>
+                        <a:t>Verification method</a:t>
+                      </a:r>
+                    </a:p>
+                  </a:txBody>
+                  <a:tcPr marL="45720" marR="45720" marT="27432" marB="27432">
+                    <a:solidFill>
+                      <a:srgbClr val="427E78"/>
+                    </a:solidFill>
+                  </a:tcPr>
+                </a:tc>
+                <a:tc>
+                  <a:txBody>
+                    <a:bodyPr/>
+                    <a:lstStyle/>
+                    <a:p>
+                      <a:pPr>
+                        <a:defRPr sz="800">
+                          <a:solidFill>
+                            <a:srgbClr val="FFFFFF"/>
+                          </a:solidFill>
+                        </a:defRPr>
+                      </a:pPr>
+                      <a:r>
+                        <a:t>Owner</a:t>
+                      </a:r>
+                    </a:p>
+                  </a:txBody>
+                  <a:tcPr marL="45720" marR="45720" marT="27432" marB="27432">
+                    <a:solidFill>
+                      <a:srgbClr val="427E78"/>
+                    </a:solidFill>
+                  </a:tcPr>
+                </a:tc>
+                <a:tc>
+                  <a:txBody>
+                    <a:bodyPr/>
+                    <a:lstStyle/>
+                    <a:p>
+                      <a:pPr>
+                        <a:defRPr sz="800">
+                          <a:solidFill>
+                            <a:srgbClr val="FFFFFF"/>
+                          </a:solidFill>
+                        </a:defRPr>
+                      </a:pPr>
+                      <a:r>
+                        <a:t>Due date</a:t>
+                      </a:r>
+                    </a:p>
+                  </a:txBody>
+                  <a:tcPr marL="45720" marR="45720" marT="27432" marB="27432">
+                    <a:solidFill>
+                      <a:srgbClr val="427E78"/>
+                    </a:solidFill>
+                  </a:tcPr>
+                </a:tc>
+                <a:tc>
+                  <a:txBody>
+                    <a:bodyPr/>
+                    <a:lstStyle/>
+                    <a:p>
+                      <a:pPr>
+                        <a:defRPr sz="800">
+                          <a:solidFill>
+                            <a:srgbClr val="FFFFFF"/>
+                          </a:solidFill>
+                        </a:defRPr>
+                      </a:pPr>
+                      <a:r>
+                        <a:t>Status</a:t>
+                      </a:r>
+                    </a:p>
+                  </a:txBody>
+                  <a:tcPr marL="45720" marR="45720" marT="27432" marB="27432">
+                    <a:solidFill>
+                      <a:srgbClr val="427E78"/>
+                    </a:solidFill>
+                  </a:tcPr>
+                </a:tc>
+              </a:tr>
+              <a:tr h="502920">
+                <a:tc>
+                  <a:txBody>
+                    <a:bodyPr/>
+                    <a:lstStyle/>
+                    <a:p>
+                      <a:pPr>
+                        <a:defRPr sz="800">
+                          <a:solidFill>
+                            <a:srgbClr val="232D37"/>
+                          </a:solidFill>
+                        </a:defRPr>
+                      </a:pPr>
+                      <a:r>
+                        <a:t>Scanner warning easy to miss</a:t>
+                      </a:r>
+                    </a:p>
+                  </a:txBody>
+                  <a:tcPr marL="45720" marR="45720" marT="27432" marB="27432">
+                    <a:solidFill>
+                      <a:srgbClr val="F8F9F7"/>
+                    </a:solidFill>
+                  </a:tcPr>
+                </a:tc>
+                <a:tc>
+                  <a:txBody>
+                    <a:bodyPr/>
+                    <a:lstStyle/>
+                    <a:p>
+                      <a:pPr>
+                        <a:defRPr sz="800">
+                          <a:solidFill>
+                            <a:srgbClr val="232D37"/>
+                          </a:solidFill>
+                        </a:defRPr>
+                      </a:pPr>
+                      <a:r>
+                        <a:t>Gemba observation and photo check</a:t>
+                      </a:r>
+                    </a:p>
+                  </a:txBody>
+                  <a:tcPr marL="45720" marR="45720" marT="27432" marB="27432">
+                    <a:solidFill>
+                      <a:srgbClr val="F8F9F7"/>
+                    </a:solidFill>
+                  </a:tcPr>
+                </a:tc>
+                <a:tc>
+                  <a:txBody>
+                    <a:bodyPr/>
+                    <a:lstStyle/>
+                    <a:p>
+                      <a:pPr>
+                        <a:defRPr sz="800">
+                          <a:solidFill>
+                            <a:srgbClr val="232D37"/>
+                          </a:solidFill>
+                        </a:defRPr>
+                      </a:pPr>
+                      <a:r>
+                        <a:t>[owner]</a:t>
+                      </a:r>
+                    </a:p>
+                  </a:txBody>
+                  <a:tcPr marL="45720" marR="45720" marT="27432" marB="27432">
+                    <a:solidFill>
+                      <a:srgbClr val="F8F9F7"/>
+                    </a:solidFill>
+                  </a:tcPr>
+                </a:tc>
+                <a:tc>
+                  <a:txBody>
+                    <a:bodyPr/>
+                    <a:lstStyle/>
+                    <a:p>
+                      <a:pPr>
+                        <a:defRPr sz="800">
+                          <a:solidFill>
+                            <a:srgbClr val="232D37"/>
+                          </a:solidFill>
+                        </a:defRPr>
+                      </a:pPr>
+                      <a:r>
+                        <a:t>[date]</a:t>
+                      </a:r>
+                    </a:p>
+                  </a:txBody>
+                  <a:tcPr marL="45720" marR="45720" marT="27432" marB="27432">
+                    <a:solidFill>
+                      <a:srgbClr val="F8F9F7"/>
+                    </a:solidFill>
+                  </a:tcPr>
+                </a:tc>
+                <a:tc>
+                  <a:txBody>
+                    <a:bodyPr/>
+                    <a:lstStyle/>
+                    <a:p>
+                      <a:pPr>
+                        <a:defRPr sz="800">
+                          <a:solidFill>
+                            <a:srgbClr val="232D37"/>
+                          </a:solidFill>
+                        </a:defRPr>
+                      </a:pPr>
+                      <a:r>
+                        <a:t>[V?]</a:t>
+                      </a:r>
+                    </a:p>
+                  </a:txBody>
+                  <a:tcPr marL="45720" marR="45720" marT="27432" marB="27432">
+                    <a:solidFill>
+                      <a:srgbClr val="F8F9F7"/>
+                    </a:solidFill>
+                  </a:tcPr>
+                </a:tc>
+              </a:tr>
+              <a:tr h="502920">
+                <a:tc>
+                  <a:txBody>
+                    <a:bodyPr/>
+                    <a:lstStyle/>
+                    <a:p>
+                      <a:pPr>
+                        <a:defRPr sz="800">
+                          <a:solidFill>
+                            <a:srgbClr val="232D37"/>
+                          </a:solidFill>
+                        </a:defRPr>
+                      </a:pPr>
+                      <a:r>
+                        <a:t>Mixed SKU paperwork</a:t>
+                      </a:r>
+                    </a:p>
+                  </a:txBody>
+                  <a:tcPr marL="45720" marR="45720" marT="27432" marB="27432">
+                    <a:solidFill>
+                      <a:srgbClr val="EEF4F3"/>
+                    </a:solidFill>
+                  </a:tcPr>
+                </a:tc>
+                <a:tc>
+                  <a:txBody>
+                    <a:bodyPr/>
+                    <a:lstStyle/>
+                    <a:p>
+                      <a:pPr>
+                        <a:defRPr sz="800">
+                          <a:solidFill>
+                            <a:srgbClr val="232D37"/>
+                          </a:solidFill>
+                        </a:defRPr>
+                      </a:pPr>
+                      <a:r>
+                        <a:t>Review packing station layout</a:t>
+                      </a:r>
+                    </a:p>
+                  </a:txBody>
+                  <a:tcPr marL="45720" marR="45720" marT="27432" marB="27432">
+                    <a:solidFill>
+                      <a:srgbClr val="EEF4F3"/>
+                    </a:solidFill>
+                  </a:tcPr>
+                </a:tc>
+                <a:tc>
+                  <a:txBody>
+                    <a:bodyPr/>
+                    <a:lstStyle/>
+                    <a:p>
+                      <a:pPr>
+                        <a:defRPr sz="800">
+                          <a:solidFill>
+                            <a:srgbClr val="232D37"/>
+                          </a:solidFill>
+                        </a:defRPr>
+                      </a:pPr>
+                      <a:r>
+                        <a:t>[owner]</a:t>
+                      </a:r>
+                    </a:p>
+                  </a:txBody>
+                  <a:tcPr marL="45720" marR="45720" marT="27432" marB="27432">
+                    <a:solidFill>
+                      <a:srgbClr val="EEF4F3"/>
+                    </a:solidFill>
+                  </a:tcPr>
+                </a:tc>
+                <a:tc>
+                  <a:txBody>
+                    <a:bodyPr/>
+                    <a:lstStyle/>
+                    <a:p>
+                      <a:pPr>
+                        <a:defRPr sz="800">
+                          <a:solidFill>
+                            <a:srgbClr val="232D37"/>
+                          </a:solidFill>
+                        </a:defRPr>
+                      </a:pPr>
+                      <a:r>
+                        <a:t>[date]</a:t>
+                      </a:r>
+                    </a:p>
+                  </a:txBody>
+                  <a:tcPr marL="45720" marR="45720" marT="27432" marB="27432">
+                    <a:solidFill>
+                      <a:srgbClr val="EEF4F3"/>
+                    </a:solidFill>
+                  </a:tcPr>
+                </a:tc>
+                <a:tc>
+                  <a:txBody>
+                    <a:bodyPr/>
+                    <a:lstStyle/>
+                    <a:p>
+                      <a:pPr>
+                        <a:defRPr sz="800">
+                          <a:solidFill>
+                            <a:srgbClr val="232D37"/>
+                          </a:solidFill>
+                        </a:defRPr>
+                      </a:pPr>
+                      <a:r>
+                        <a:t>[V?]</a:t>
+                      </a:r>
+                    </a:p>
+                  </a:txBody>
+                  <a:tcPr marL="45720" marR="45720" marT="27432" marB="27432">
+                    <a:solidFill>
+                      <a:srgbClr val="EEF4F3"/>
+                    </a:solidFill>
+                  </a:tcPr>
+                </a:tc>
+              </a:tr>
+              <a:tr h="502920">
+                <a:tc>
+                  <a:txBody>
+                    <a:bodyPr/>
+                    <a:lstStyle/>
+                    <a:p>
+                      <a:pPr>
+                        <a:defRPr sz="800">
+                          <a:solidFill>
+                            <a:srgbClr val="232D37"/>
+                          </a:solidFill>
+                        </a:defRPr>
+                      </a:pPr>
+                      <a:r>
+                        <a:t>[cause]</a:t>
+                      </a:r>
+                    </a:p>
+                  </a:txBody>
+                  <a:tcPr marL="45720" marR="45720" marT="27432" marB="27432">
+                    <a:solidFill>
+                      <a:srgbClr val="F8F9F7"/>
+                    </a:solidFill>
+                  </a:tcPr>
+                </a:tc>
+                <a:tc>
+                  <a:txBody>
+                    <a:bodyPr/>
+                    <a:lstStyle/>
+                    <a:p>
+                      <a:pPr>
+                        <a:defRPr sz="800">
+                          <a:solidFill>
+                            <a:srgbClr val="232D37"/>
+                          </a:solidFill>
+                        </a:defRPr>
+                      </a:pPr>
+                      <a:r>
+                        <a:t>[check, data review, or 5 Whys]</a:t>
+                      </a:r>
+                    </a:p>
+                  </a:txBody>
+                  <a:tcPr marL="45720" marR="45720" marT="27432" marB="27432">
+                    <a:solidFill>
+                      <a:srgbClr val="F8F9F7"/>
+                    </a:solidFill>
+                  </a:tcPr>
+                </a:tc>
+                <a:tc>
+                  <a:txBody>
+                    <a:bodyPr/>
+                    <a:lstStyle/>
+                    <a:p>
+                      <a:pPr>
+                        <a:defRPr sz="800">
+                          <a:solidFill>
+                            <a:srgbClr val="232D37"/>
+                          </a:solidFill>
+                        </a:defRPr>
+                      </a:pPr>
+                      <a:r>
+                        <a:t>[owner]</a:t>
+                      </a:r>
+                    </a:p>
+                  </a:txBody>
+                  <a:tcPr marL="45720" marR="45720" marT="27432" marB="27432">
+                    <a:solidFill>
+                      <a:srgbClr val="F8F9F7"/>
+                    </a:solidFill>
+                  </a:tcPr>
+                </a:tc>
+                <a:tc>
+                  <a:txBody>
+                    <a:bodyPr/>
+                    <a:lstStyle/>
+                    <a:p>
+                      <a:pPr>
+                        <a:defRPr sz="800">
+                          <a:solidFill>
+                            <a:srgbClr val="232D37"/>
+                          </a:solidFill>
+                        </a:defRPr>
+                      </a:pPr>
+                      <a:r>
+                        <a:t>[date]</a:t>
+                      </a:r>
+                    </a:p>
+                  </a:txBody>
+                  <a:tcPr marL="45720" marR="45720" marT="27432" marB="27432">
+                    <a:solidFill>
+                      <a:srgbClr val="F8F9F7"/>
+                    </a:solidFill>
+                  </a:tcPr>
+                </a:tc>
+                <a:tc>
+                  <a:txBody>
+                    <a:bodyPr/>
+                    <a:lstStyle/>
+                    <a:p>
+                      <a:pPr>
+                        <a:defRPr sz="800">
+                          <a:solidFill>
+                            <a:srgbClr val="232D37"/>
+                          </a:solidFill>
+                        </a:defRPr>
+                      </a:pPr>
+                      <a:r>
+                        <a:t>[S/V?/V/X]</a:t>
+                      </a:r>
+                    </a:p>
+                  </a:txBody>
+                  <a:tcPr marL="45720" marR="45720" marT="27432" marB="27432">
+                    <a:solidFill>
+                      <a:srgbClr val="F8F9F7"/>
+                    </a:solidFill>
+                  </a:tcPr>
+                </a:tc>
+              </a:tr>
+            </a:tbl>
+          </a:graphicData>
+        </a:graphic>
+      </p:graphicFrame>
       <p:sp>
         <p:nvSpPr>
           <p:cNvPr id="6" name="Rounded Rectangle 5"/>
@@ -7107,8 +9682,8 @@
         </p:nvSpPr>
         <p:spPr>
           <a:xfrm>
-            <a:off x="640080" y="1691640"/>
-            <a:ext cx="5394960" cy="4206240"/>
+            <a:off x="685800" y="3703320"/>
+            <a:ext cx="5166360" cy="1417320"/>
           </a:xfrm>
           <a:prstGeom prst="roundRect">
             <a:avLst/>
@@ -7147,55 +9722,43 @@
                   <a:srgbClr val="1B2733"/>
                 </a:solidFill>
               </a:rPr>
-              <a:t>Demo structure</a:t>
-            </a:r>
-          </a:p>
-          <a:p>
-            <a:pPr>
-              <a:defRPr sz="1100">
-                <a:solidFill>
-                  <a:srgbClr val="2D3741"/>
-                </a:solidFill>
-              </a:defRPr>
-            </a:pPr>
-            <a:r>
-              <a:t>Change data only: replace branch causes and evidence notes.</a:t>
-            </a:r>
-          </a:p>
-          <a:p>
-            <a:pPr>
-              <a:defRPr sz="1100">
-                <a:solidFill>
-                  <a:srgbClr val="2D3741"/>
-                </a:solidFill>
-              </a:defRPr>
-            </a:pPr>
-            <a:r>
-              <a:t>Effect statement: {{effect_statement}}</a:t>
-            </a:r>
-          </a:p>
-          <a:p>
-            <a:pPr>
-              <a:defRPr sz="1100">
-                <a:solidFill>
-                  <a:srgbClr val="2D3741"/>
-                </a:solidFill>
-              </a:defRPr>
-            </a:pPr>
-            <a:r>
-              <a:t>Cause branches: {{cause_branches}}</a:t>
-            </a:r>
-          </a:p>
-          <a:p>
-            <a:pPr>
-              <a:defRPr sz="1100">
-                <a:solidFill>
-                  <a:srgbClr val="2D3741"/>
-                </a:solidFill>
-              </a:defRPr>
-            </a:pPr>
-            <a:r>
-              <a:t>Verified causes: {{verified_causes}}</a:t>
+              <a:t>Use this plan</a:t>
+            </a:r>
+          </a:p>
+          <a:p>
+            <a:pPr>
+              <a:defRPr sz="1100">
+                <a:solidFill>
+                  <a:srgbClr val="2D3741"/>
+                </a:solidFill>
+              </a:defRPr>
+            </a:pPr>
+            <a:r>
+              <a:t>Select only causes that can be checked.</a:t>
+            </a:r>
+          </a:p>
+          <a:p>
+            <a:pPr>
+              <a:defRPr sz="1100">
+                <a:solidFill>
+                  <a:srgbClr val="2D3741"/>
+                </a:solidFill>
+              </a:defRPr>
+            </a:pPr>
+            <a:r>
+              <a:t>Assign owner and due date before countermeasure selection.</a:t>
+            </a:r>
+          </a:p>
+          <a:p>
+            <a:pPr>
+              <a:defRPr sz="1100">
+                <a:solidFill>
+                  <a:srgbClr val="2D3741"/>
+                </a:solidFill>
+              </a:defRPr>
+            </a:pPr>
+            <a:r>
+              <a:t>Update Status after verification evidence is reviewed.</a:t>
             </a:r>
           </a:p>
         </p:txBody>
@@ -7208,8 +9771,8 @@
         </p:nvSpPr>
         <p:spPr>
           <a:xfrm>
-            <a:off x="6355080" y="1691640"/>
-            <a:ext cx="4892040" cy="4206240"/>
+            <a:off x="6263640" y="3703320"/>
+            <a:ext cx="5166360" cy="1417320"/>
           </a:xfrm>
           <a:prstGeom prst="roundRect">
             <a:avLst/>
@@ -7248,79 +9811,55 @@
                   <a:srgbClr val="1B2733"/>
                 </a:solidFill>
               </a:rPr>
-              <a:t>Reserved placeholders</a:t>
-            </a:r>
-          </a:p>
-          <a:p>
-            <a:pPr>
-              <a:defRPr sz="1100">
-                <a:solidFill>
-                  <a:srgbClr val="2D3741"/>
-                </a:solidFill>
-              </a:defRPr>
-            </a:pPr>
-            <a:r>
-              <a:t>{{method_name}}</a:t>
-            </a:r>
-          </a:p>
-          <a:p>
-            <a:pPr>
-              <a:defRPr sz="1100">
-                <a:solidFill>
-                  <a:srgbClr val="2D3741"/>
-                </a:solidFill>
-              </a:defRPr>
-            </a:pPr>
-            <a:r>
-              <a:t>{{qcc_stage}}</a:t>
-            </a:r>
-          </a:p>
-          <a:p>
-            <a:pPr>
-              <a:defRPr sz="1100">
-                <a:solidFill>
-                  <a:srgbClr val="2D3741"/>
-                </a:solidFill>
-              </a:defRPr>
-            </a:pPr>
-            <a:r>
-              <a:t>{{demo_label}}</a:t>
-            </a:r>
-          </a:p>
-          <a:p>
-            <a:pPr>
-              <a:defRPr sz="1100">
-                <a:solidFill>
-                  <a:srgbClr val="2D3741"/>
-                </a:solidFill>
-              </a:defRPr>
-            </a:pPr>
-            <a:r>
-              <a:t>{{effect_statement}}</a:t>
-            </a:r>
-          </a:p>
-          <a:p>
-            <a:pPr>
-              <a:defRPr sz="1100">
-                <a:solidFill>
-                  <a:srgbClr val="2D3741"/>
-                </a:solidFill>
-              </a:defRPr>
-            </a:pPr>
-            <a:r>
-              <a:t>{{cause_branches}}</a:t>
-            </a:r>
-          </a:p>
-          <a:p>
-            <a:pPr>
-              <a:defRPr sz="1100">
-                <a:solidFill>
-                  <a:srgbClr val="2D3741"/>
-                </a:solidFill>
-              </a:defRPr>
-            </a:pPr>
-            <a:r>
-              <a:t>{{verified_causes}}</a:t>
+              <a:t>Review risks</a:t>
+            </a:r>
+          </a:p>
+          <a:p>
+            <a:pPr>
+              <a:defRPr sz="1100">
+                <a:solidFill>
+                  <a:srgbClr val="2D3741"/>
+                </a:solidFill>
+              </a:defRPr>
+            </a:pPr>
+            <a:r>
+              <a:t>No verification method.</a:t>
+            </a:r>
+          </a:p>
+          <a:p>
+            <a:pPr>
+              <a:defRPr sz="1100">
+                <a:solidFill>
+                  <a:srgbClr val="2D3741"/>
+                </a:solidFill>
+              </a:defRPr>
+            </a:pPr>
+            <a:r>
+              <a:t>Owner or due date missing.</a:t>
+            </a:r>
+          </a:p>
+          <a:p>
+            <a:pPr>
+              <a:defRPr sz="1100">
+                <a:solidFill>
+                  <a:srgbClr val="2D3741"/>
+                </a:solidFill>
+              </a:defRPr>
+            </a:pPr>
+            <a:r>
+              <a:t>Status marked [V] without evidence.</a:t>
+            </a:r>
+          </a:p>
+          <a:p>
+            <a:pPr>
+              <a:defRPr sz="1100">
+                <a:solidFill>
+                  <a:srgbClr val="2D3741"/>
+                </a:solidFill>
+              </a:defRPr>
+            </a:pPr>
+            <a:r>
+              <a:t>Cause moved to countermeasure too early.</a:t>
             </a:r>
           </a:p>
         </p:txBody>

</xml_diff>

<commit_message>
M6: refine Fishbone diagram visual design
</commit_message>
<xml_diff>
--- a/templates/ppt/methods/fishbone-diagram-template.pptx
+++ b/templates/ppt/methods/fishbone-diagram-template.pptx
@@ -8132,7 +8132,7 @@
                   <a:srgbClr val="1B2733"/>
                 </a:solidFill>
               </a:rPr>
-              <a:t>Editable fishbone diagram</a:t>
+              <a:t>Clean editable fishbone</a:t>
             </a:r>
           </a:p>
         </p:txBody>
@@ -8222,7 +8222,7 @@
         <p:spPr>
           <a:xfrm>
             <a:off x="640080" y="1051560"/>
-            <a:ext cx="4937760" cy="329184"/>
+            <a:ext cx="5669280" cy="329184"/>
           </a:xfrm>
           <a:prstGeom prst="roundRect">
             <a:avLst/>
@@ -8261,27 +8261,27 @@
                   <a:srgbClr val="664B11"/>
                 </a:solidFill>
               </a:rPr>
-              <a:t>Replace demo causes with project evidence</a:t>
-            </a:r>
-          </a:p>
-        </p:txBody>
-      </p:sp>
-      <p:sp>
-        <p:nvSpPr>
-          <p:cNvPr id="6" name="TextBox 5"/>
-          <p:cNvSpPr txBox="1"/>
-          <p:nvPr/>
-        </p:nvSpPr>
-        <p:spPr>
-          <a:xfrm>
-            <a:off x="8641080" y="2468880"/>
-            <a:ext cx="2514600" cy="685800"/>
-          </a:xfrm>
-          <a:prstGeom prst="rect">
+              <a:t>Replace short cause labels; keep details in the plan</a:t>
+            </a:r>
+          </a:p>
+        </p:txBody>
+      </p:sp>
+      <p:sp>
+        <p:nvSpPr>
+          <p:cNvPr id="6" name="Rounded Rectangle 5"/>
+          <p:cNvSpPr/>
+          <p:nvPr/>
+        </p:nvSpPr>
+        <p:spPr>
+          <a:xfrm>
+            <a:off x="8549640" y="2404872"/>
+            <a:ext cx="2697480" cy="822960"/>
+          </a:xfrm>
+          <a:prstGeom prst="roundRect">
             <a:avLst/>
           </a:prstGeom>
           <a:solidFill>
-            <a:srgbClr val="EEF4F3"/>
+            <a:srgbClr val="E8F1EF"/>
           </a:solidFill>
           <a:ln>
             <a:solidFill>
@@ -8289,12 +8289,25 @@
             </a:solidFill>
           </a:ln>
         </p:spPr>
-        <p:txBody>
-          <a:bodyPr wrap="square" lIns="73152" rIns="73152">
-            <a:spAutoFit/>
-          </a:bodyPr>
-          <a:lstStyle/>
-          <a:p>
+        <p:style>
+          <a:lnRef idx="1">
+            <a:schemeClr val="accent1"/>
+          </a:lnRef>
+          <a:fillRef idx="3">
+            <a:schemeClr val="accent1"/>
+          </a:fillRef>
+          <a:effectRef idx="2">
+            <a:schemeClr val="accent1"/>
+          </a:effectRef>
+          <a:fontRef idx="minor">
+            <a:schemeClr val="lt1"/>
+          </a:fontRef>
+        </p:style>
+        <p:txBody>
+          <a:bodyPr rtlCol="0" anchor="ctr" wrap="square" lIns="54864" rIns="54864" tIns="18288" bIns="18288"/>
+          <a:lstStyle/>
+          <a:p>
+            <a:pPr algn="ctr"/>
             <a:r>
               <a:rPr sz="1300" b="1">
                 <a:solidFill>
@@ -8315,15 +8328,15 @@
         </p:nvCxnSpPr>
         <p:spPr>
           <a:xfrm>
-            <a:off x="960120" y="2816352"/>
-            <a:ext cx="7680960" cy="0"/>
+            <a:off x="960120" y="2834640"/>
+            <a:ext cx="7589520" cy="0"/>
           </a:xfrm>
           <a:prstGeom prst="line">
             <a:avLst/>
           </a:prstGeom>
-          <a:ln w="28575">
+          <a:ln w="31750">
             <a:solidFill>
-              <a:srgbClr val="427E78"/>
+              <a:srgbClr val="2A6762"/>
             </a:solidFill>
           </a:ln>
         </p:spPr>
@@ -8350,15 +8363,15 @@
         </p:nvCxnSpPr>
         <p:spPr>
           <a:xfrm flipV="1">
-            <a:off x="1143000" y="1234440"/>
-            <a:ext cx="1371600" cy="1581912"/>
+            <a:off x="1508760" y="1234440"/>
+            <a:ext cx="1188720" cy="1600200"/>
           </a:xfrm>
           <a:prstGeom prst="line">
             <a:avLst/>
           </a:prstGeom>
-          <a:ln w="19050">
+          <a:ln w="17145">
             <a:solidFill>
-              <a:srgbClr val="788986"/>
+              <a:srgbClr val="69807C"/>
             </a:solidFill>
           </a:ln>
         </p:spPr>
@@ -8379,16 +8392,1025 @@
       </p:cxnSp>
       <p:sp>
         <p:nvSpPr>
-          <p:cNvPr id="9" name="TextBox 8"/>
+          <p:cNvPr id="9" name="Rounded Rectangle 8"/>
+          <p:cNvSpPr/>
+          <p:nvPr/>
+        </p:nvSpPr>
+        <p:spPr>
+          <a:xfrm>
+            <a:off x="2194560" y="365760"/>
+            <a:ext cx="1005840" cy="320040"/>
+          </a:xfrm>
+          <a:prstGeom prst="roundRect">
+            <a:avLst/>
+          </a:prstGeom>
+          <a:solidFill>
+            <a:srgbClr val="427E78"/>
+          </a:solidFill>
+          <a:ln>
+            <a:solidFill>
+              <a:srgbClr val="427E78"/>
+            </a:solidFill>
+          </a:ln>
+        </p:spPr>
+        <p:style>
+          <a:lnRef idx="1">
+            <a:schemeClr val="accent1"/>
+          </a:lnRef>
+          <a:fillRef idx="3">
+            <a:schemeClr val="accent1"/>
+          </a:fillRef>
+          <a:effectRef idx="2">
+            <a:schemeClr val="accent1"/>
+          </a:effectRef>
+          <a:fontRef idx="minor">
+            <a:schemeClr val="lt1"/>
+          </a:fontRef>
+        </p:style>
+        <p:txBody>
+          <a:bodyPr rtlCol="0" anchor="ctr" wrap="square" lIns="54864" rIns="54864" tIns="18288" bIns="18288"/>
+          <a:lstStyle/>
+          <a:p>
+            <a:pPr algn="ctr"/>
+            <a:r>
+              <a:rPr sz="800" b="1">
+                <a:solidFill>
+                  <a:srgbClr val="FFFFFF"/>
+                </a:solidFill>
+              </a:rPr>
+              <a:t>Method</a:t>
+            </a:r>
+          </a:p>
+        </p:txBody>
+      </p:sp>
+      <p:sp>
+        <p:nvSpPr>
+          <p:cNvPr id="10" name="Rounded Rectangle 9"/>
+          <p:cNvSpPr/>
+          <p:nvPr/>
+        </p:nvSpPr>
+        <p:spPr>
+          <a:xfrm>
+            <a:off x="2221992" y="941832"/>
+            <a:ext cx="329184" cy="256032"/>
+          </a:xfrm>
+          <a:prstGeom prst="roundRect">
+            <a:avLst/>
+          </a:prstGeom>
+          <a:solidFill>
+            <a:srgbClr val="ECEFF1"/>
+          </a:solidFill>
+          <a:ln>
+            <a:solidFill>
+              <a:srgbClr val="737D82"/>
+            </a:solidFill>
+          </a:ln>
+        </p:spPr>
+        <p:style>
+          <a:lnRef idx="1">
+            <a:schemeClr val="accent1"/>
+          </a:lnRef>
+          <a:fillRef idx="3">
+            <a:schemeClr val="accent1"/>
+          </a:fillRef>
+          <a:effectRef idx="2">
+            <a:schemeClr val="accent1"/>
+          </a:effectRef>
+          <a:fontRef idx="minor">
+            <a:schemeClr val="lt1"/>
+          </a:fontRef>
+        </p:style>
+        <p:txBody>
+          <a:bodyPr rtlCol="0" anchor="ctr" wrap="square" lIns="54864" rIns="54864" tIns="18288" bIns="18288"/>
+          <a:lstStyle/>
+          <a:p>
+            <a:pPr algn="ctr"/>
+            <a:r>
+              <a:rPr sz="700" b="1">
+                <a:solidFill>
+                  <a:srgbClr val="394247"/>
+                </a:solidFill>
+              </a:rPr>
+              <a:t>[S]</a:t>
+            </a:r>
+          </a:p>
+        </p:txBody>
+      </p:sp>
+      <p:sp>
+        <p:nvSpPr>
+          <p:cNvPr id="11" name="TextBox 10"/>
           <p:cNvSpPr txBox="1"/>
           <p:nvPr/>
         </p:nvSpPr>
         <p:spPr>
           <a:xfrm>
-            <a:off x="1947672" y="612648"/>
-            <a:ext cx="1874519" cy="658368"/>
+            <a:off x="2606040" y="923544"/>
+            <a:ext cx="1508760" cy="347472"/>
           </a:xfrm>
           <a:prstGeom prst="rect">
+            <a:avLst/>
+          </a:prstGeom>
+          <a:noFill/>
+        </p:spPr>
+        <p:txBody>
+          <a:bodyPr wrap="square" lIns="73152" rIns="73152">
+            <a:spAutoFit/>
+          </a:bodyPr>
+          <a:lstStyle/>
+          <a:p>
+            <a:r>
+              <a:rPr sz="900" b="0">
+                <a:solidFill>
+                  <a:srgbClr val="232D37"/>
+                </a:solidFill>
+              </a:rPr>
+              <a:t>Late label check</a:t>
+            </a:r>
+          </a:p>
+        </p:txBody>
+      </p:sp>
+      <p:cxnSp>
+        <p:nvCxnSpPr>
+          <p:cNvPr id="12" name="Connector 11"/>
+          <p:cNvCxnSpPr/>
+          <p:nvPr/>
+        </p:nvCxnSpPr>
+        <p:spPr>
+          <a:xfrm flipV="1">
+            <a:off x="3429000" y="1234440"/>
+            <a:ext cx="1188720" cy="1600200"/>
+          </a:xfrm>
+          <a:prstGeom prst="line">
+            <a:avLst/>
+          </a:prstGeom>
+          <a:ln w="17145">
+            <a:solidFill>
+              <a:srgbClr val="69807C"/>
+            </a:solidFill>
+          </a:ln>
+        </p:spPr>
+        <p:style>
+          <a:lnRef idx="2">
+            <a:schemeClr val="accent1"/>
+          </a:lnRef>
+          <a:fillRef idx="0">
+            <a:schemeClr val="accent1"/>
+          </a:fillRef>
+          <a:effectRef idx="1">
+            <a:schemeClr val="accent1"/>
+          </a:effectRef>
+          <a:fontRef idx="minor">
+            <a:schemeClr val="tx1"/>
+          </a:fontRef>
+        </p:style>
+      </p:cxnSp>
+      <p:sp>
+        <p:nvSpPr>
+          <p:cNvPr id="13" name="Rounded Rectangle 12"/>
+          <p:cNvSpPr/>
+          <p:nvPr/>
+        </p:nvSpPr>
+        <p:spPr>
+          <a:xfrm>
+            <a:off x="4114800" y="365760"/>
+            <a:ext cx="1005840" cy="320040"/>
+          </a:xfrm>
+          <a:prstGeom prst="roundRect">
+            <a:avLst/>
+          </a:prstGeom>
+          <a:solidFill>
+            <a:srgbClr val="427E78"/>
+          </a:solidFill>
+          <a:ln>
+            <a:solidFill>
+              <a:srgbClr val="427E78"/>
+            </a:solidFill>
+          </a:ln>
+        </p:spPr>
+        <p:style>
+          <a:lnRef idx="1">
+            <a:schemeClr val="accent1"/>
+          </a:lnRef>
+          <a:fillRef idx="3">
+            <a:schemeClr val="accent1"/>
+          </a:fillRef>
+          <a:effectRef idx="2">
+            <a:schemeClr val="accent1"/>
+          </a:effectRef>
+          <a:fontRef idx="minor">
+            <a:schemeClr val="lt1"/>
+          </a:fontRef>
+        </p:style>
+        <p:txBody>
+          <a:bodyPr rtlCol="0" anchor="ctr" wrap="square" lIns="54864" rIns="54864" tIns="18288" bIns="18288"/>
+          <a:lstStyle/>
+          <a:p>
+            <a:pPr algn="ctr"/>
+            <a:r>
+              <a:rPr sz="800" b="1">
+                <a:solidFill>
+                  <a:srgbClr val="FFFFFF"/>
+                </a:solidFill>
+              </a:rPr>
+              <a:t>Machine</a:t>
+            </a:r>
+          </a:p>
+        </p:txBody>
+      </p:sp>
+      <p:sp>
+        <p:nvSpPr>
+          <p:cNvPr id="14" name="Rounded Rectangle 13"/>
+          <p:cNvSpPr/>
+          <p:nvPr/>
+        </p:nvSpPr>
+        <p:spPr>
+          <a:xfrm>
+            <a:off x="4142231" y="941832"/>
+            <a:ext cx="420624" cy="256032"/>
+          </a:xfrm>
+          <a:prstGeom prst="roundRect">
+            <a:avLst/>
+          </a:prstGeom>
+          <a:solidFill>
+            <a:srgbClr val="FFF2CC"/>
+          </a:solidFill>
+          <a:ln>
+            <a:solidFill>
+              <a:srgbClr val="D69F2E"/>
+            </a:solidFill>
+          </a:ln>
+        </p:spPr>
+        <p:style>
+          <a:lnRef idx="1">
+            <a:schemeClr val="accent1"/>
+          </a:lnRef>
+          <a:fillRef idx="3">
+            <a:schemeClr val="accent1"/>
+          </a:fillRef>
+          <a:effectRef idx="2">
+            <a:schemeClr val="accent1"/>
+          </a:effectRef>
+          <a:fontRef idx="minor">
+            <a:schemeClr val="lt1"/>
+          </a:fontRef>
+        </p:style>
+        <p:txBody>
+          <a:bodyPr rtlCol="0" anchor="ctr" wrap="square" lIns="54864" rIns="54864" tIns="18288" bIns="18288"/>
+          <a:lstStyle/>
+          <a:p>
+            <a:pPr algn="ctr"/>
+            <a:r>
+              <a:rPr sz="700" b="1">
+                <a:solidFill>
+                  <a:srgbClr val="664B11"/>
+                </a:solidFill>
+              </a:rPr>
+              <a:t>[V?]</a:t>
+            </a:r>
+          </a:p>
+        </p:txBody>
+      </p:sp>
+      <p:sp>
+        <p:nvSpPr>
+          <p:cNvPr id="15" name="TextBox 14"/>
+          <p:cNvSpPr txBox="1"/>
+          <p:nvPr/>
+        </p:nvSpPr>
+        <p:spPr>
+          <a:xfrm>
+            <a:off x="4526280" y="923544"/>
+            <a:ext cx="1508760" cy="347472"/>
+          </a:xfrm>
+          <a:prstGeom prst="rect">
+            <a:avLst/>
+          </a:prstGeom>
+          <a:noFill/>
+        </p:spPr>
+        <p:txBody>
+          <a:bodyPr wrap="square" lIns="73152" rIns="73152">
+            <a:spAutoFit/>
+          </a:bodyPr>
+          <a:lstStyle/>
+          <a:p>
+            <a:r>
+              <a:rPr sz="900" b="0">
+                <a:solidFill>
+                  <a:srgbClr val="232D37"/>
+                </a:solidFill>
+              </a:rPr>
+              <a:t>Scanner warning hidden</a:t>
+            </a:r>
+          </a:p>
+        </p:txBody>
+      </p:sp>
+      <p:cxnSp>
+        <p:nvCxnSpPr>
+          <p:cNvPr id="16" name="Connector 15"/>
+          <p:cNvCxnSpPr/>
+          <p:nvPr/>
+        </p:nvCxnSpPr>
+        <p:spPr>
+          <a:xfrm flipV="1">
+            <a:off x="5349240" y="1234440"/>
+            <a:ext cx="1188720" cy="1600200"/>
+          </a:xfrm>
+          <a:prstGeom prst="line">
+            <a:avLst/>
+          </a:prstGeom>
+          <a:ln w="17145">
+            <a:solidFill>
+              <a:srgbClr val="69807C"/>
+            </a:solidFill>
+          </a:ln>
+        </p:spPr>
+        <p:style>
+          <a:lnRef idx="2">
+            <a:schemeClr val="accent1"/>
+          </a:lnRef>
+          <a:fillRef idx="0">
+            <a:schemeClr val="accent1"/>
+          </a:fillRef>
+          <a:effectRef idx="1">
+            <a:schemeClr val="accent1"/>
+          </a:effectRef>
+          <a:fontRef idx="minor">
+            <a:schemeClr val="tx1"/>
+          </a:fontRef>
+        </p:style>
+      </p:cxnSp>
+      <p:sp>
+        <p:nvSpPr>
+          <p:cNvPr id="17" name="Rounded Rectangle 16"/>
+          <p:cNvSpPr/>
+          <p:nvPr/>
+        </p:nvSpPr>
+        <p:spPr>
+          <a:xfrm>
+            <a:off x="6035040" y="365760"/>
+            <a:ext cx="1005840" cy="320040"/>
+          </a:xfrm>
+          <a:prstGeom prst="roundRect">
+            <a:avLst/>
+          </a:prstGeom>
+          <a:solidFill>
+            <a:srgbClr val="427E78"/>
+          </a:solidFill>
+          <a:ln>
+            <a:solidFill>
+              <a:srgbClr val="427E78"/>
+            </a:solidFill>
+          </a:ln>
+        </p:spPr>
+        <p:style>
+          <a:lnRef idx="1">
+            <a:schemeClr val="accent1"/>
+          </a:lnRef>
+          <a:fillRef idx="3">
+            <a:schemeClr val="accent1"/>
+          </a:fillRef>
+          <a:effectRef idx="2">
+            <a:schemeClr val="accent1"/>
+          </a:effectRef>
+          <a:fontRef idx="minor">
+            <a:schemeClr val="lt1"/>
+          </a:fontRef>
+        </p:style>
+        <p:txBody>
+          <a:bodyPr rtlCol="0" anchor="ctr" wrap="square" lIns="54864" rIns="54864" tIns="18288" bIns="18288"/>
+          <a:lstStyle/>
+          <a:p>
+            <a:pPr algn="ctr"/>
+            <a:r>
+              <a:rPr sz="800" b="1">
+                <a:solidFill>
+                  <a:srgbClr val="FFFFFF"/>
+                </a:solidFill>
+              </a:rPr>
+              <a:t>Material</a:t>
+            </a:r>
+          </a:p>
+        </p:txBody>
+      </p:sp>
+      <p:sp>
+        <p:nvSpPr>
+          <p:cNvPr id="18" name="Rounded Rectangle 17"/>
+          <p:cNvSpPr/>
+          <p:nvPr/>
+        </p:nvSpPr>
+        <p:spPr>
+          <a:xfrm>
+            <a:off x="6062472" y="941832"/>
+            <a:ext cx="329184" cy="256032"/>
+          </a:xfrm>
+          <a:prstGeom prst="roundRect">
+            <a:avLst/>
+          </a:prstGeom>
+          <a:solidFill>
+            <a:srgbClr val="ECEFF1"/>
+          </a:solidFill>
+          <a:ln>
+            <a:solidFill>
+              <a:srgbClr val="737D82"/>
+            </a:solidFill>
+          </a:ln>
+        </p:spPr>
+        <p:style>
+          <a:lnRef idx="1">
+            <a:schemeClr val="accent1"/>
+          </a:lnRef>
+          <a:fillRef idx="3">
+            <a:schemeClr val="accent1"/>
+          </a:fillRef>
+          <a:effectRef idx="2">
+            <a:schemeClr val="accent1"/>
+          </a:effectRef>
+          <a:fontRef idx="minor">
+            <a:schemeClr val="lt1"/>
+          </a:fontRef>
+        </p:style>
+        <p:txBody>
+          <a:bodyPr rtlCol="0" anchor="ctr" wrap="square" lIns="54864" rIns="54864" tIns="18288" bIns="18288"/>
+          <a:lstStyle/>
+          <a:p>
+            <a:pPr algn="ctr"/>
+            <a:r>
+              <a:rPr sz="700" b="1">
+                <a:solidFill>
+                  <a:srgbClr val="394247"/>
+                </a:solidFill>
+              </a:rPr>
+              <a:t>[S]</a:t>
+            </a:r>
+          </a:p>
+        </p:txBody>
+      </p:sp>
+      <p:sp>
+        <p:nvSpPr>
+          <p:cNvPr id="19" name="TextBox 18"/>
+          <p:cNvSpPr txBox="1"/>
+          <p:nvPr/>
+        </p:nvSpPr>
+        <p:spPr>
+          <a:xfrm>
+            <a:off x="6446520" y="923544"/>
+            <a:ext cx="1508760" cy="347472"/>
+          </a:xfrm>
+          <a:prstGeom prst="rect">
+            <a:avLst/>
+          </a:prstGeom>
+          <a:noFill/>
+        </p:spPr>
+        <p:txBody>
+          <a:bodyPr wrap="square" lIns="73152" rIns="73152">
+            <a:spAutoFit/>
+          </a:bodyPr>
+          <a:lstStyle/>
+          <a:p>
+            <a:r>
+              <a:rPr sz="900" b="0">
+                <a:solidFill>
+                  <a:srgbClr val="232D37"/>
+                </a:solidFill>
+              </a:rPr>
+              <a:t>Similar roll colors</a:t>
+            </a:r>
+          </a:p>
+        </p:txBody>
+      </p:sp>
+      <p:cxnSp>
+        <p:nvCxnSpPr>
+          <p:cNvPr id="20" name="Connector 19"/>
+          <p:cNvCxnSpPr/>
+          <p:nvPr/>
+        </p:nvCxnSpPr>
+        <p:spPr>
+          <a:xfrm>
+            <a:off x="1508760" y="2834640"/>
+            <a:ext cx="1188720" cy="1600200"/>
+          </a:xfrm>
+          <a:prstGeom prst="line">
+            <a:avLst/>
+          </a:prstGeom>
+          <a:ln w="17145">
+            <a:solidFill>
+              <a:srgbClr val="69807C"/>
+            </a:solidFill>
+          </a:ln>
+        </p:spPr>
+        <p:style>
+          <a:lnRef idx="2">
+            <a:schemeClr val="accent1"/>
+          </a:lnRef>
+          <a:fillRef idx="0">
+            <a:schemeClr val="accent1"/>
+          </a:fillRef>
+          <a:effectRef idx="1">
+            <a:schemeClr val="accent1"/>
+          </a:effectRef>
+          <a:fontRef idx="minor">
+            <a:schemeClr val="tx1"/>
+          </a:fontRef>
+        </p:style>
+      </p:cxnSp>
+      <p:sp>
+        <p:nvSpPr>
+          <p:cNvPr id="21" name="Rounded Rectangle 20"/>
+          <p:cNvSpPr/>
+          <p:nvPr/>
+        </p:nvSpPr>
+        <p:spPr>
+          <a:xfrm>
+            <a:off x="2194560" y="4544568"/>
+            <a:ext cx="1005840" cy="320040"/>
+          </a:xfrm>
+          <a:prstGeom prst="roundRect">
+            <a:avLst/>
+          </a:prstGeom>
+          <a:solidFill>
+            <a:srgbClr val="427E78"/>
+          </a:solidFill>
+          <a:ln>
+            <a:solidFill>
+              <a:srgbClr val="427E78"/>
+            </a:solidFill>
+          </a:ln>
+        </p:spPr>
+        <p:style>
+          <a:lnRef idx="1">
+            <a:schemeClr val="accent1"/>
+          </a:lnRef>
+          <a:fillRef idx="3">
+            <a:schemeClr val="accent1"/>
+          </a:fillRef>
+          <a:effectRef idx="2">
+            <a:schemeClr val="accent1"/>
+          </a:effectRef>
+          <a:fontRef idx="minor">
+            <a:schemeClr val="lt1"/>
+          </a:fontRef>
+        </p:style>
+        <p:txBody>
+          <a:bodyPr rtlCol="0" anchor="ctr" wrap="square" lIns="54864" rIns="54864" tIns="18288" bIns="18288"/>
+          <a:lstStyle/>
+          <a:p>
+            <a:pPr algn="ctr"/>
+            <a:r>
+              <a:rPr sz="800" b="1">
+                <a:solidFill>
+                  <a:srgbClr val="FFFFFF"/>
+                </a:solidFill>
+              </a:rPr>
+              <a:t>People</a:t>
+            </a:r>
+          </a:p>
+        </p:txBody>
+      </p:sp>
+      <p:sp>
+        <p:nvSpPr>
+          <p:cNvPr id="22" name="Rounded Rectangle 21"/>
+          <p:cNvSpPr/>
+          <p:nvPr/>
+        </p:nvSpPr>
+        <p:spPr>
+          <a:xfrm>
+            <a:off x="2221992" y="5020055"/>
+            <a:ext cx="329184" cy="256032"/>
+          </a:xfrm>
+          <a:prstGeom prst="roundRect">
+            <a:avLst/>
+          </a:prstGeom>
+          <a:solidFill>
+            <a:srgbClr val="ECEFF1"/>
+          </a:solidFill>
+          <a:ln>
+            <a:solidFill>
+              <a:srgbClr val="737D82"/>
+            </a:solidFill>
+          </a:ln>
+        </p:spPr>
+        <p:style>
+          <a:lnRef idx="1">
+            <a:schemeClr val="accent1"/>
+          </a:lnRef>
+          <a:fillRef idx="3">
+            <a:schemeClr val="accent1"/>
+          </a:fillRef>
+          <a:effectRef idx="2">
+            <a:schemeClr val="accent1"/>
+          </a:effectRef>
+          <a:fontRef idx="minor">
+            <a:schemeClr val="lt1"/>
+          </a:fontRef>
+        </p:style>
+        <p:txBody>
+          <a:bodyPr rtlCol="0" anchor="ctr" wrap="square" lIns="54864" rIns="54864" tIns="18288" bIns="18288"/>
+          <a:lstStyle/>
+          <a:p>
+            <a:pPr algn="ctr"/>
+            <a:r>
+              <a:rPr sz="700" b="1">
+                <a:solidFill>
+                  <a:srgbClr val="394247"/>
+                </a:solidFill>
+              </a:rPr>
+              <a:t>[S]</a:t>
+            </a:r>
+          </a:p>
+        </p:txBody>
+      </p:sp>
+      <p:sp>
+        <p:nvSpPr>
+          <p:cNvPr id="23" name="TextBox 22"/>
+          <p:cNvSpPr txBox="1"/>
+          <p:nvPr/>
+        </p:nvSpPr>
+        <p:spPr>
+          <a:xfrm>
+            <a:off x="2606040" y="5001768"/>
+            <a:ext cx="1508760" cy="347472"/>
+          </a:xfrm>
+          <a:prstGeom prst="rect">
+            <a:avLst/>
+          </a:prstGeom>
+          <a:noFill/>
+        </p:spPr>
+        <p:txBody>
+          <a:bodyPr wrap="square" lIns="73152" rIns="73152">
+            <a:spAutoFit/>
+          </a:bodyPr>
+          <a:lstStyle/>
+          <a:p>
+            <a:r>
+              <a:rPr sz="900" b="0">
+                <a:solidFill>
+                  <a:srgbClr val="232D37"/>
+                </a:solidFill>
+              </a:rPr>
+              <a:t>New operators rotate in</a:t>
+            </a:r>
+          </a:p>
+        </p:txBody>
+      </p:sp>
+      <p:cxnSp>
+        <p:nvCxnSpPr>
+          <p:cNvPr id="24" name="Connector 23"/>
+          <p:cNvCxnSpPr/>
+          <p:nvPr/>
+        </p:nvCxnSpPr>
+        <p:spPr>
+          <a:xfrm>
+            <a:off x="3429000" y="2834640"/>
+            <a:ext cx="1188720" cy="1600200"/>
+          </a:xfrm>
+          <a:prstGeom prst="line">
+            <a:avLst/>
+          </a:prstGeom>
+          <a:ln w="17145">
+            <a:solidFill>
+              <a:srgbClr val="69807C"/>
+            </a:solidFill>
+          </a:ln>
+        </p:spPr>
+        <p:style>
+          <a:lnRef idx="2">
+            <a:schemeClr val="accent1"/>
+          </a:lnRef>
+          <a:fillRef idx="0">
+            <a:schemeClr val="accent1"/>
+          </a:fillRef>
+          <a:effectRef idx="1">
+            <a:schemeClr val="accent1"/>
+          </a:effectRef>
+          <a:fontRef idx="minor">
+            <a:schemeClr val="tx1"/>
+          </a:fontRef>
+        </p:style>
+      </p:cxnSp>
+      <p:sp>
+        <p:nvSpPr>
+          <p:cNvPr id="25" name="Rounded Rectangle 24"/>
+          <p:cNvSpPr/>
+          <p:nvPr/>
+        </p:nvSpPr>
+        <p:spPr>
+          <a:xfrm>
+            <a:off x="4114800" y="4544568"/>
+            <a:ext cx="1005840" cy="320040"/>
+          </a:xfrm>
+          <a:prstGeom prst="roundRect">
+            <a:avLst/>
+          </a:prstGeom>
+          <a:solidFill>
+            <a:srgbClr val="427E78"/>
+          </a:solidFill>
+          <a:ln>
+            <a:solidFill>
+              <a:srgbClr val="427E78"/>
+            </a:solidFill>
+          </a:ln>
+        </p:spPr>
+        <p:style>
+          <a:lnRef idx="1">
+            <a:schemeClr val="accent1"/>
+          </a:lnRef>
+          <a:fillRef idx="3">
+            <a:schemeClr val="accent1"/>
+          </a:fillRef>
+          <a:effectRef idx="2">
+            <a:schemeClr val="accent1"/>
+          </a:effectRef>
+          <a:fontRef idx="minor">
+            <a:schemeClr val="lt1"/>
+          </a:fontRef>
+        </p:style>
+        <p:txBody>
+          <a:bodyPr rtlCol="0" anchor="ctr" wrap="square" lIns="54864" rIns="54864" tIns="18288" bIns="18288"/>
+          <a:lstStyle/>
+          <a:p>
+            <a:pPr algn="ctr"/>
+            <a:r>
+              <a:rPr sz="800" b="1">
+                <a:solidFill>
+                  <a:srgbClr val="FFFFFF"/>
+                </a:solidFill>
+              </a:rPr>
+              <a:t>Environment</a:t>
+            </a:r>
+          </a:p>
+        </p:txBody>
+      </p:sp>
+      <p:sp>
+        <p:nvSpPr>
+          <p:cNvPr id="26" name="Rounded Rectangle 25"/>
+          <p:cNvSpPr/>
+          <p:nvPr/>
+        </p:nvSpPr>
+        <p:spPr>
+          <a:xfrm>
+            <a:off x="4142231" y="5020055"/>
+            <a:ext cx="420624" cy="256032"/>
+          </a:xfrm>
+          <a:prstGeom prst="roundRect">
+            <a:avLst/>
+          </a:prstGeom>
+          <a:solidFill>
+            <a:srgbClr val="FFF2CC"/>
+          </a:solidFill>
+          <a:ln>
+            <a:solidFill>
+              <a:srgbClr val="D69F2E"/>
+            </a:solidFill>
+          </a:ln>
+        </p:spPr>
+        <p:style>
+          <a:lnRef idx="1">
+            <a:schemeClr val="accent1"/>
+          </a:lnRef>
+          <a:fillRef idx="3">
+            <a:schemeClr val="accent1"/>
+          </a:fillRef>
+          <a:effectRef idx="2">
+            <a:schemeClr val="accent1"/>
+          </a:effectRef>
+          <a:fontRef idx="minor">
+            <a:schemeClr val="lt1"/>
+          </a:fontRef>
+        </p:style>
+        <p:txBody>
+          <a:bodyPr rtlCol="0" anchor="ctr" wrap="square" lIns="54864" rIns="54864" tIns="18288" bIns="18288"/>
+          <a:lstStyle/>
+          <a:p>
+            <a:pPr algn="ctr"/>
+            <a:r>
+              <a:rPr sz="700" b="1">
+                <a:solidFill>
+                  <a:srgbClr val="664B11"/>
+                </a:solidFill>
+              </a:rPr>
+              <a:t>[V?]</a:t>
+            </a:r>
+          </a:p>
+        </p:txBody>
+      </p:sp>
+      <p:sp>
+        <p:nvSpPr>
+          <p:cNvPr id="27" name="TextBox 26"/>
+          <p:cNvSpPr txBox="1"/>
+          <p:nvPr/>
+        </p:nvSpPr>
+        <p:spPr>
+          <a:xfrm>
+            <a:off x="4526280" y="5001768"/>
+            <a:ext cx="1508760" cy="347472"/>
+          </a:xfrm>
+          <a:prstGeom prst="rect">
+            <a:avLst/>
+          </a:prstGeom>
+          <a:noFill/>
+        </p:spPr>
+        <p:txBody>
+          <a:bodyPr wrap="square" lIns="73152" rIns="73152">
+            <a:spAutoFit/>
+          </a:bodyPr>
+          <a:lstStyle/>
+          <a:p>
+            <a:r>
+              <a:rPr sz="900" b="0">
+                <a:solidFill>
+                  <a:srgbClr val="232D37"/>
+                </a:solidFill>
+              </a:rPr>
+              <a:t>Mixed SKU paperwork</a:t>
+            </a:r>
+          </a:p>
+        </p:txBody>
+      </p:sp>
+      <p:cxnSp>
+        <p:nvCxnSpPr>
+          <p:cNvPr id="28" name="Connector 27"/>
+          <p:cNvCxnSpPr/>
+          <p:nvPr/>
+        </p:nvCxnSpPr>
+        <p:spPr>
+          <a:xfrm>
+            <a:off x="5349240" y="2834640"/>
+            <a:ext cx="1188720" cy="1600200"/>
+          </a:xfrm>
+          <a:prstGeom prst="line">
+            <a:avLst/>
+          </a:prstGeom>
+          <a:ln w="17145">
+            <a:solidFill>
+              <a:srgbClr val="69807C"/>
+            </a:solidFill>
+          </a:ln>
+        </p:spPr>
+        <p:style>
+          <a:lnRef idx="2">
+            <a:schemeClr val="accent1"/>
+          </a:lnRef>
+          <a:fillRef idx="0">
+            <a:schemeClr val="accent1"/>
+          </a:fillRef>
+          <a:effectRef idx="1">
+            <a:schemeClr val="accent1"/>
+          </a:effectRef>
+          <a:fontRef idx="minor">
+            <a:schemeClr val="tx1"/>
+          </a:fontRef>
+        </p:style>
+      </p:cxnSp>
+      <p:sp>
+        <p:nvSpPr>
+          <p:cNvPr id="29" name="Rounded Rectangle 28"/>
+          <p:cNvSpPr/>
+          <p:nvPr/>
+        </p:nvSpPr>
+        <p:spPr>
+          <a:xfrm>
+            <a:off x="6035040" y="4544568"/>
+            <a:ext cx="1005840" cy="320040"/>
+          </a:xfrm>
+          <a:prstGeom prst="roundRect">
+            <a:avLst/>
+          </a:prstGeom>
+          <a:solidFill>
+            <a:srgbClr val="427E78"/>
+          </a:solidFill>
+          <a:ln>
+            <a:solidFill>
+              <a:srgbClr val="427E78"/>
+            </a:solidFill>
+          </a:ln>
+        </p:spPr>
+        <p:style>
+          <a:lnRef idx="1">
+            <a:schemeClr val="accent1"/>
+          </a:lnRef>
+          <a:fillRef idx="3">
+            <a:schemeClr val="accent1"/>
+          </a:fillRef>
+          <a:effectRef idx="2">
+            <a:schemeClr val="accent1"/>
+          </a:effectRef>
+          <a:fontRef idx="minor">
+            <a:schemeClr val="lt1"/>
+          </a:fontRef>
+        </p:style>
+        <p:txBody>
+          <a:bodyPr rtlCol="0" anchor="ctr" wrap="square" lIns="54864" rIns="54864" tIns="18288" bIns="18288"/>
+          <a:lstStyle/>
+          <a:p>
+            <a:pPr algn="ctr"/>
+            <a:r>
+              <a:rPr sz="800" b="1">
+                <a:solidFill>
+                  <a:srgbClr val="FFFFFF"/>
+                </a:solidFill>
+              </a:rPr>
+              <a:t>Measurement</a:t>
+            </a:r>
+          </a:p>
+        </p:txBody>
+      </p:sp>
+      <p:sp>
+        <p:nvSpPr>
+          <p:cNvPr id="30" name="Rounded Rectangle 29"/>
+          <p:cNvSpPr/>
+          <p:nvPr/>
+        </p:nvSpPr>
+        <p:spPr>
+          <a:xfrm>
+            <a:off x="6062472" y="5020055"/>
+            <a:ext cx="329184" cy="256032"/>
+          </a:xfrm>
+          <a:prstGeom prst="roundRect">
+            <a:avLst/>
+          </a:prstGeom>
+          <a:solidFill>
+            <a:srgbClr val="F6E6E2"/>
+          </a:solidFill>
+          <a:ln>
+            <a:solidFill>
+              <a:srgbClr val="AD5B4D"/>
+            </a:solidFill>
+          </a:ln>
+        </p:spPr>
+        <p:style>
+          <a:lnRef idx="1">
+            <a:schemeClr val="accent1"/>
+          </a:lnRef>
+          <a:fillRef idx="3">
+            <a:schemeClr val="accent1"/>
+          </a:fillRef>
+          <a:effectRef idx="2">
+            <a:schemeClr val="accent1"/>
+          </a:effectRef>
+          <a:fontRef idx="minor">
+            <a:schemeClr val="lt1"/>
+          </a:fontRef>
+        </p:style>
+        <p:txBody>
+          <a:bodyPr rtlCol="0" anchor="ctr" wrap="square" lIns="54864" rIns="54864" tIns="18288" bIns="18288"/>
+          <a:lstStyle/>
+          <a:p>
+            <a:pPr algn="ctr"/>
+            <a:r>
+              <a:rPr sz="700" b="1">
+                <a:solidFill>
+                  <a:srgbClr val="75342A"/>
+                </a:solidFill>
+              </a:rPr>
+              <a:t>[X]</a:t>
+            </a:r>
+          </a:p>
+        </p:txBody>
+      </p:sp>
+      <p:sp>
+        <p:nvSpPr>
+          <p:cNvPr id="31" name="TextBox 30"/>
+          <p:cNvSpPr txBox="1"/>
+          <p:nvPr/>
+        </p:nvSpPr>
+        <p:spPr>
+          <a:xfrm>
+            <a:off x="6446520" y="5001768"/>
+            <a:ext cx="1508760" cy="347472"/>
+          </a:xfrm>
+          <a:prstGeom prst="rect">
+            <a:avLst/>
+          </a:prstGeom>
+          <a:noFill/>
+        </p:spPr>
+        <p:txBody>
+          <a:bodyPr wrap="square" lIns="73152" rIns="73152">
+            <a:spAutoFit/>
+          </a:bodyPr>
+          <a:lstStyle/>
+          <a:p>
+            <a:r>
+              <a:rPr sz="900" b="0">
+                <a:solidFill>
+                  <a:srgbClr val="232D37"/>
+                </a:solidFill>
+              </a:rPr>
+              <a:t>Audit form mismatch</a:t>
+            </a:r>
+          </a:p>
+        </p:txBody>
+      </p:sp>
+      <p:sp>
+        <p:nvSpPr>
+          <p:cNvPr id="32" name="Rounded Rectangle 31"/>
+          <p:cNvSpPr/>
+          <p:nvPr/>
+        </p:nvSpPr>
+        <p:spPr>
+          <a:xfrm>
+            <a:off x="640080" y="5230368"/>
+            <a:ext cx="3749039" cy="914400"/>
+          </a:xfrm>
+          <a:prstGeom prst="roundRect">
             <a:avLst/>
           </a:prstGeom>
           <a:solidFill>
@@ -8400,71 +9422,84 @@
             </a:solidFill>
           </a:ln>
         </p:spPr>
-        <p:txBody>
-          <a:bodyPr wrap="square" lIns="73152" rIns="73152">
-            <a:spAutoFit/>
-          </a:bodyPr>
-          <a:lstStyle/>
-          <a:p>
-            <a:r>
-              <a:rPr sz="900" b="0">
-                <a:solidFill>
-                  <a:srgbClr val="232D37"/>
-                </a:solidFill>
-              </a:rPr>
-              <a:t>Method
-S: Label check after boxing</a:t>
-            </a:r>
-          </a:p>
-        </p:txBody>
-      </p:sp>
-      <p:cxnSp>
-        <p:nvCxnSpPr>
-          <p:cNvPr id="10" name="Connector 9"/>
-          <p:cNvCxnSpPr/>
-          <p:nvPr/>
-        </p:nvCxnSpPr>
-        <p:spPr>
-          <a:xfrm flipV="1">
-            <a:off x="3246120" y="1234440"/>
-            <a:ext cx="1234440" cy="1581912"/>
-          </a:xfrm>
-          <a:prstGeom prst="line">
-            <a:avLst/>
-          </a:prstGeom>
-          <a:ln w="19050">
-            <a:solidFill>
-              <a:srgbClr val="788986"/>
-            </a:solidFill>
-          </a:ln>
-        </p:spPr>
         <p:style>
-          <a:lnRef idx="2">
+          <a:lnRef idx="1">
             <a:schemeClr val="accent1"/>
           </a:lnRef>
-          <a:fillRef idx="0">
+          <a:fillRef idx="3">
             <a:schemeClr val="accent1"/>
           </a:fillRef>
-          <a:effectRef idx="1">
+          <a:effectRef idx="2">
             <a:schemeClr val="accent1"/>
           </a:effectRef>
           <a:fontRef idx="minor">
-            <a:schemeClr val="tx1"/>
+            <a:schemeClr val="lt1"/>
           </a:fontRef>
         </p:style>
-      </p:cxnSp>
-      <p:sp>
-        <p:nvSpPr>
-          <p:cNvPr id="11" name="TextBox 10"/>
-          <p:cNvSpPr txBox="1"/>
-          <p:nvPr/>
-        </p:nvSpPr>
-        <p:spPr>
-          <a:xfrm>
-            <a:off x="3913632" y="612648"/>
-            <a:ext cx="1874519" cy="658368"/>
-          </a:xfrm>
-          <a:prstGeom prst="rect">
+        <p:txBody>
+          <a:bodyPr rtlCol="0" anchor="t" lIns="164592" rIns="164592" tIns="128016"/>
+          <a:lstStyle/>
+          <a:p>
+            <a:pPr algn="ctr"/>
+            <a:r>
+              <a:rPr b="1" sz="1500">
+                <a:solidFill>
+                  <a:srgbClr val="1B2733"/>
+                </a:solidFill>
+              </a:rPr>
+              <a:t>Visual design rule</a:t>
+            </a:r>
+          </a:p>
+          <a:p>
+            <a:pPr>
+              <a:defRPr sz="1100">
+                <a:solidFill>
+                  <a:srgbClr val="2D3741"/>
+                </a:solidFill>
+              </a:defRPr>
+            </a:pPr>
+            <a:r>
+              <a:t>Editable fishbone diagram.</a:t>
+            </a:r>
+          </a:p>
+          <a:p>
+            <a:pPr>
+              <a:defRPr sz="1100">
+                <a:solidFill>
+                  <a:srgbClr val="2D3741"/>
+                </a:solidFill>
+              </a:defRPr>
+            </a:pPr>
+            <a:r>
+              <a:t>Centered fishbone composition with Branch label capsules.</a:t>
+            </a:r>
+          </a:p>
+          <a:p>
+            <a:pPr>
+              <a:defRPr sz="1100">
+                <a:solidFill>
+                  <a:srgbClr val="2D3741"/>
+                </a:solidFill>
+              </a:defRPr>
+            </a:pPr>
+            <a:r>
+              <a:t>Short cause labels on the diagram.</a:t>
+            </a:r>
+          </a:p>
+        </p:txBody>
+      </p:sp>
+      <p:sp>
+        <p:nvSpPr>
+          <p:cNvPr id="33" name="Rounded Rectangle 32"/>
+          <p:cNvSpPr/>
+          <p:nvPr/>
+        </p:nvSpPr>
+        <p:spPr>
+          <a:xfrm>
+            <a:off x="4617720" y="5230368"/>
+            <a:ext cx="2926080" cy="914400"/>
+          </a:xfrm>
+          <a:prstGeom prst="roundRect">
             <a:avLst/>
           </a:prstGeom>
           <a:solidFill>
@@ -8476,71 +9511,60 @@
             </a:solidFill>
           </a:ln>
         </p:spPr>
-        <p:txBody>
-          <a:bodyPr wrap="square" lIns="73152" rIns="73152">
-            <a:spAutoFit/>
-          </a:bodyPr>
-          <a:lstStyle/>
-          <a:p>
-            <a:r>
-              <a:rPr sz="900" b="0">
-                <a:solidFill>
-                  <a:srgbClr val="232D37"/>
-                </a:solidFill>
-              </a:rPr>
-              <a:t>Machine
-V?: Scanner warning easy to miss</a:t>
-            </a:r>
-          </a:p>
-        </p:txBody>
-      </p:sp>
-      <p:cxnSp>
-        <p:nvCxnSpPr>
-          <p:cNvPr id="12" name="Connector 11"/>
-          <p:cNvCxnSpPr/>
-          <p:nvPr/>
-        </p:nvCxnSpPr>
-        <p:spPr>
-          <a:xfrm flipV="1">
-            <a:off x="5257800" y="1234440"/>
-            <a:ext cx="1234440" cy="1581912"/>
-          </a:xfrm>
-          <a:prstGeom prst="line">
-            <a:avLst/>
-          </a:prstGeom>
-          <a:ln w="19050">
-            <a:solidFill>
-              <a:srgbClr val="788986"/>
-            </a:solidFill>
-          </a:ln>
-        </p:spPr>
         <p:style>
-          <a:lnRef idx="2">
+          <a:lnRef idx="1">
             <a:schemeClr val="accent1"/>
           </a:lnRef>
-          <a:fillRef idx="0">
+          <a:fillRef idx="3">
             <a:schemeClr val="accent1"/>
           </a:fillRef>
-          <a:effectRef idx="1">
+          <a:effectRef idx="2">
             <a:schemeClr val="accent1"/>
           </a:effectRef>
           <a:fontRef idx="minor">
-            <a:schemeClr val="tx1"/>
+            <a:schemeClr val="lt1"/>
           </a:fontRef>
         </p:style>
-      </p:cxnSp>
-      <p:sp>
-        <p:nvSpPr>
-          <p:cNvPr id="13" name="TextBox 12"/>
-          <p:cNvSpPr txBox="1"/>
-          <p:nvPr/>
-        </p:nvSpPr>
-        <p:spPr>
-          <a:xfrm>
-            <a:off x="5925312" y="612648"/>
-            <a:ext cx="1874519" cy="658368"/>
-          </a:xfrm>
-          <a:prstGeom prst="rect">
+        <p:txBody>
+          <a:bodyPr rtlCol="0" anchor="t" lIns="164592" rIns="164592" tIns="128016"/>
+          <a:lstStyle/>
+          <a:p>
+            <a:pPr algn="ctr"/>
+            <a:r>
+              <a:rPr b="1" sz="1500">
+                <a:solidFill>
+                  <a:srgbClr val="1B2733"/>
+                </a:solidFill>
+              </a:rPr>
+              <a:t>Status badges</a:t>
+            </a:r>
+          </a:p>
+          <a:p>
+            <a:pPr>
+              <a:defRPr sz="1100">
+                <a:solidFill>
+                  <a:srgbClr val="2D3741"/>
+                </a:solidFill>
+              </a:defRPr>
+            </a:pPr>
+            <a:r>
+              <a:t>[S] Suspected | [V?] Verify | [V] Verified | [X] Rejected</a:t>
+            </a:r>
+          </a:p>
+        </p:txBody>
+      </p:sp>
+      <p:sp>
+        <p:nvSpPr>
+          <p:cNvPr id="34" name="Rounded Rectangle 33"/>
+          <p:cNvSpPr/>
+          <p:nvPr/>
+        </p:nvSpPr>
+        <p:spPr>
+          <a:xfrm>
+            <a:off x="7818120" y="4251960"/>
+            <a:ext cx="3429000" cy="1600200"/>
+          </a:xfrm>
+          <a:prstGeom prst="roundRect">
             <a:avLst/>
           </a:prstGeom>
           <a:solidFill>
@@ -8552,275 +9576,6 @@
             </a:solidFill>
           </a:ln>
         </p:spPr>
-        <p:txBody>
-          <a:bodyPr wrap="square" lIns="73152" rIns="73152">
-            <a:spAutoFit/>
-          </a:bodyPr>
-          <a:lstStyle/>
-          <a:p>
-            <a:r>
-              <a:rPr sz="900" b="0">
-                <a:solidFill>
-                  <a:srgbClr val="232D37"/>
-                </a:solidFill>
-              </a:rPr>
-              <a:t>Material
-S: Similar label roll colors</a:t>
-            </a:r>
-          </a:p>
-        </p:txBody>
-      </p:sp>
-      <p:cxnSp>
-        <p:nvCxnSpPr>
-          <p:cNvPr id="14" name="Connector 13"/>
-          <p:cNvCxnSpPr/>
-          <p:nvPr/>
-        </p:nvCxnSpPr>
-        <p:spPr>
-          <a:xfrm>
-            <a:off x="1234440" y="2816352"/>
-            <a:ext cx="1371600" cy="1344168"/>
-          </a:xfrm>
-          <a:prstGeom prst="line">
-            <a:avLst/>
-          </a:prstGeom>
-          <a:ln w="19050">
-            <a:solidFill>
-              <a:srgbClr val="788986"/>
-            </a:solidFill>
-          </a:ln>
-        </p:spPr>
-        <p:style>
-          <a:lnRef idx="2">
-            <a:schemeClr val="accent1"/>
-          </a:lnRef>
-          <a:fillRef idx="0">
-            <a:schemeClr val="accent1"/>
-          </a:fillRef>
-          <a:effectRef idx="1">
-            <a:schemeClr val="accent1"/>
-          </a:effectRef>
-          <a:fontRef idx="minor">
-            <a:schemeClr val="tx1"/>
-          </a:fontRef>
-        </p:style>
-      </p:cxnSp>
-      <p:sp>
-        <p:nvSpPr>
-          <p:cNvPr id="15" name="TextBox 14"/>
-          <p:cNvSpPr txBox="1"/>
-          <p:nvPr/>
-        </p:nvSpPr>
-        <p:spPr>
-          <a:xfrm>
-            <a:off x="2039112" y="4251959"/>
-            <a:ext cx="1874519" cy="658368"/>
-          </a:xfrm>
-          <a:prstGeom prst="rect">
-            <a:avLst/>
-          </a:prstGeom>
-          <a:solidFill>
-            <a:srgbClr val="F8F9F7"/>
-          </a:solidFill>
-          <a:ln>
-            <a:solidFill>
-              <a:srgbClr val="BEC4BF"/>
-            </a:solidFill>
-          </a:ln>
-        </p:spPr>
-        <p:txBody>
-          <a:bodyPr wrap="square" lIns="73152" rIns="73152">
-            <a:spAutoFit/>
-          </a:bodyPr>
-          <a:lstStyle/>
-          <a:p>
-            <a:r>
-              <a:rPr sz="900" b="0">
-                <a:solidFill>
-                  <a:srgbClr val="232D37"/>
-                </a:solidFill>
-              </a:rPr>
-              <a:t>People
-S: New operators rotate in</a:t>
-            </a:r>
-          </a:p>
-        </p:txBody>
-      </p:sp>
-      <p:cxnSp>
-        <p:nvCxnSpPr>
-          <p:cNvPr id="16" name="Connector 15"/>
-          <p:cNvCxnSpPr/>
-          <p:nvPr/>
-        </p:nvCxnSpPr>
-        <p:spPr>
-          <a:xfrm>
-            <a:off x="3429000" y="2816352"/>
-            <a:ext cx="1371600" cy="1344168"/>
-          </a:xfrm>
-          <a:prstGeom prst="line">
-            <a:avLst/>
-          </a:prstGeom>
-          <a:ln w="19050">
-            <a:solidFill>
-              <a:srgbClr val="788986"/>
-            </a:solidFill>
-          </a:ln>
-        </p:spPr>
-        <p:style>
-          <a:lnRef idx="2">
-            <a:schemeClr val="accent1"/>
-          </a:lnRef>
-          <a:fillRef idx="0">
-            <a:schemeClr val="accent1"/>
-          </a:fillRef>
-          <a:effectRef idx="1">
-            <a:schemeClr val="accent1"/>
-          </a:effectRef>
-          <a:fontRef idx="minor">
-            <a:schemeClr val="tx1"/>
-          </a:fontRef>
-        </p:style>
-      </p:cxnSp>
-      <p:sp>
-        <p:nvSpPr>
-          <p:cNvPr id="17" name="TextBox 16"/>
-          <p:cNvSpPr txBox="1"/>
-          <p:nvPr/>
-        </p:nvSpPr>
-        <p:spPr>
-          <a:xfrm>
-            <a:off x="4233672" y="4251959"/>
-            <a:ext cx="1874519" cy="658368"/>
-          </a:xfrm>
-          <a:prstGeom prst="rect">
-            <a:avLst/>
-          </a:prstGeom>
-          <a:solidFill>
-            <a:srgbClr val="F8F9F7"/>
-          </a:solidFill>
-          <a:ln>
-            <a:solidFill>
-              <a:srgbClr val="BEC4BF"/>
-            </a:solidFill>
-          </a:ln>
-        </p:spPr>
-        <p:txBody>
-          <a:bodyPr wrap="square" lIns="73152" rIns="73152">
-            <a:spAutoFit/>
-          </a:bodyPr>
-          <a:lstStyle/>
-          <a:p>
-            <a:r>
-              <a:rPr sz="900" b="0">
-                <a:solidFill>
-                  <a:srgbClr val="232D37"/>
-                </a:solidFill>
-              </a:rPr>
-              <a:t>Environment
-V?: Mixed SKU paperwork</a:t>
-            </a:r>
-          </a:p>
-        </p:txBody>
-      </p:sp>
-      <p:cxnSp>
-        <p:nvCxnSpPr>
-          <p:cNvPr id="18" name="Connector 17"/>
-          <p:cNvCxnSpPr/>
-          <p:nvPr/>
-        </p:nvCxnSpPr>
-        <p:spPr>
-          <a:xfrm>
-            <a:off x="5532120" y="2816352"/>
-            <a:ext cx="1371600" cy="1344168"/>
-          </a:xfrm>
-          <a:prstGeom prst="line">
-            <a:avLst/>
-          </a:prstGeom>
-          <a:ln w="19050">
-            <a:solidFill>
-              <a:srgbClr val="788986"/>
-            </a:solidFill>
-          </a:ln>
-        </p:spPr>
-        <p:style>
-          <a:lnRef idx="2">
-            <a:schemeClr val="accent1"/>
-          </a:lnRef>
-          <a:fillRef idx="0">
-            <a:schemeClr val="accent1"/>
-          </a:fillRef>
-          <a:effectRef idx="1">
-            <a:schemeClr val="accent1"/>
-          </a:effectRef>
-          <a:fontRef idx="minor">
-            <a:schemeClr val="tx1"/>
-          </a:fontRef>
-        </p:style>
-      </p:cxnSp>
-      <p:sp>
-        <p:nvSpPr>
-          <p:cNvPr id="19" name="TextBox 18"/>
-          <p:cNvSpPr txBox="1"/>
-          <p:nvPr/>
-        </p:nvSpPr>
-        <p:spPr>
-          <a:xfrm>
-            <a:off x="6336792" y="4251959"/>
-            <a:ext cx="1874519" cy="658368"/>
-          </a:xfrm>
-          <a:prstGeom prst="rect">
-            <a:avLst/>
-          </a:prstGeom>
-          <a:solidFill>
-            <a:srgbClr val="F8F9F7"/>
-          </a:solidFill>
-          <a:ln>
-            <a:solidFill>
-              <a:srgbClr val="BEC4BF"/>
-            </a:solidFill>
-          </a:ln>
-        </p:spPr>
-        <p:txBody>
-          <a:bodyPr wrap="square" lIns="73152" rIns="73152">
-            <a:spAutoFit/>
-          </a:bodyPr>
-          <a:lstStyle/>
-          <a:p>
-            <a:r>
-              <a:rPr sz="900" b="0">
-                <a:solidFill>
-                  <a:srgbClr val="232D37"/>
-                </a:solidFill>
-              </a:rPr>
-              <a:t>Measurement
-X: Audit form not root cause</a:t>
-            </a:r>
-          </a:p>
-        </p:txBody>
-      </p:sp>
-      <p:sp>
-        <p:nvSpPr>
-          <p:cNvPr id="20" name="Rounded Rectangle 19"/>
-          <p:cNvSpPr/>
-          <p:nvPr/>
-        </p:nvSpPr>
-        <p:spPr>
-          <a:xfrm>
-            <a:off x="640080" y="5349240"/>
-            <a:ext cx="3657600" cy="777240"/>
-          </a:xfrm>
-          <a:prstGeom prst="roundRect">
-            <a:avLst/>
-          </a:prstGeom>
-          <a:solidFill>
-            <a:srgbClr val="F8F9F7"/>
-          </a:solidFill>
-          <a:ln>
-            <a:solidFill>
-              <a:srgbClr val="BEC4BF"/>
-            </a:solidFill>
-          </a:ln>
-        </p:spPr>
         <p:style>
           <a:lnRef idx="1">
             <a:schemeClr val="accent1"/>
@@ -8846,136 +9601,6 @@
                   <a:srgbClr val="1B2733"/>
                 </a:solidFill>
               </a:rPr>
-              <a:t>Verification marker legend</a:t>
-            </a:r>
-          </a:p>
-          <a:p>
-            <a:pPr>
-              <a:defRPr sz="1100">
-                <a:solidFill>
-                  <a:srgbClr val="2D3741"/>
-                </a:solidFill>
-              </a:defRPr>
-            </a:pPr>
-            <a:r>
-              <a:t>[S] Suspected | [V?] Selected for verification | [V] Verified | [X] Rejected</a:t>
-            </a:r>
-          </a:p>
-        </p:txBody>
-      </p:sp>
-      <p:sp>
-        <p:nvSpPr>
-          <p:cNvPr id="21" name="Rounded Rectangle 20"/>
-          <p:cNvSpPr/>
-          <p:nvPr/>
-        </p:nvSpPr>
-        <p:spPr>
-          <a:xfrm>
-            <a:off x="4526280" y="5349240"/>
-            <a:ext cx="3246120" cy="777240"/>
-          </a:xfrm>
-          <a:prstGeom prst="roundRect">
-            <a:avLst/>
-          </a:prstGeom>
-          <a:solidFill>
-            <a:srgbClr val="F8F9F7"/>
-          </a:solidFill>
-          <a:ln>
-            <a:solidFill>
-              <a:srgbClr val="BEC4BF"/>
-            </a:solidFill>
-          </a:ln>
-        </p:spPr>
-        <p:style>
-          <a:lnRef idx="1">
-            <a:schemeClr val="accent1"/>
-          </a:lnRef>
-          <a:fillRef idx="3">
-            <a:schemeClr val="accent1"/>
-          </a:fillRef>
-          <a:effectRef idx="2">
-            <a:schemeClr val="accent1"/>
-          </a:effectRef>
-          <a:fontRef idx="minor">
-            <a:schemeClr val="lt1"/>
-          </a:fontRef>
-        </p:style>
-        <p:txBody>
-          <a:bodyPr rtlCol="0" anchor="t" lIns="164592" rIns="164592" tIns="128016"/>
-          <a:lstStyle/>
-          <a:p>
-            <a:pPr algn="ctr"/>
-            <a:r>
-              <a:rPr b="1" sz="1500">
-                <a:solidFill>
-                  <a:srgbClr val="1B2733"/>
-                </a:solidFill>
-              </a:rPr>
-              <a:t>Selected causes to verify</a:t>
-            </a:r>
-          </a:p>
-          <a:p>
-            <a:pPr>
-              <a:defRPr sz="1100">
-                <a:solidFill>
-                  <a:srgbClr val="2D3741"/>
-                </a:solidFill>
-              </a:defRPr>
-            </a:pPr>
-            <a:r>
-              <a:t>Choose 2-3 causes with clear verification methods.</a:t>
-            </a:r>
-          </a:p>
-        </p:txBody>
-      </p:sp>
-      <p:sp>
-        <p:nvSpPr>
-          <p:cNvPr id="22" name="Rounded Rectangle 21"/>
-          <p:cNvSpPr/>
-          <p:nvPr/>
-        </p:nvSpPr>
-        <p:spPr>
-          <a:xfrm>
-            <a:off x="8001000" y="4160520"/>
-            <a:ext cx="3337560" cy="1508760"/>
-          </a:xfrm>
-          <a:prstGeom prst="roundRect">
-            <a:avLst/>
-          </a:prstGeom>
-          <a:solidFill>
-            <a:srgbClr val="F8F9F7"/>
-          </a:solidFill>
-          <a:ln>
-            <a:solidFill>
-              <a:srgbClr val="BEC4BF"/>
-            </a:solidFill>
-          </a:ln>
-        </p:spPr>
-        <p:style>
-          <a:lnRef idx="1">
-            <a:schemeClr val="accent1"/>
-          </a:lnRef>
-          <a:fillRef idx="3">
-            <a:schemeClr val="accent1"/>
-          </a:fillRef>
-          <a:effectRef idx="2">
-            <a:schemeClr val="accent1"/>
-          </a:effectRef>
-          <a:fontRef idx="minor">
-            <a:schemeClr val="lt1"/>
-          </a:fontRef>
-        </p:style>
-        <p:txBody>
-          <a:bodyPr rtlCol="0" anchor="t" lIns="164592" rIns="164592" tIns="128016"/>
-          <a:lstStyle/>
-          <a:p>
-            <a:pPr algn="ctr"/>
-            <a:r>
-              <a:rPr b="1" sz="1500">
-                <a:solidFill>
-                  <a:srgbClr val="1B2733"/>
-                </a:solidFill>
-              </a:rPr>
               <a:t>Evidence/source fields</a:t>
             </a:r>
           </a:p>
@@ -8988,6 +9613,18 @@
               </a:defRPr>
             </a:pPr>
             <a:r>
+              <a:t>Selected causes to verify: [V?] only.</a:t>
+            </a:r>
+          </a:p>
+          <a:p>
+            <a:pPr>
+              <a:defRPr sz="1100">
+                <a:solidFill>
+                  <a:srgbClr val="2D3741"/>
+                </a:solidFill>
+              </a:defRPr>
+            </a:pPr>
+            <a:r>
               <a:t>Source: [team session, gemba, records].</a:t>
             </a:r>
           </a:p>
@@ -9012,14 +9649,14 @@
               </a:defRPr>
             </a:pPr>
             <a:r>
-              <a:t>Prepared by/date: [name/date].</a:t>
-            </a:r>
-          </a:p>
-        </p:txBody>
-      </p:sp>
-      <p:sp>
-        <p:nvSpPr>
-          <p:cNvPr id="23" name="TextBox 22"/>
+              <a:t>Details stay in verification plan.</a:t>
+            </a:r>
+          </a:p>
+        </p:txBody>
+      </p:sp>
+      <p:sp>
+        <p:nvSpPr>
+          <p:cNvPr id="35" name="TextBox 34"/>
           <p:cNvSpPr txBox="1"/>
           <p:nvPr/>
         </p:nvSpPr>

</xml_diff>